<commit_message>
Correcciones BD II y Arquitectura + iconos
Co-Authored-By: Claude Opus 5 <noreply@anthropic.com>
</commit_message>
<xml_diff>
--- a/Arquitectura de Sistemas Computacionales/Clases/Clase 1 - Introduccion a arquitecturas cloud/Presentacion.pptx
+++ b/Arquitectura de Sistemas Computacionales/Clases/Clase 1 - Introduccion a arquitecturas cloud/Presentacion.pptx
@@ -16,6 +16,8 @@
     <p:sldId id="264" r:id="rId15"/>
     <p:sldId id="265" r:id="rId16"/>
     <p:sldId id="266" r:id="rId17"/>
+    <p:sldId id="267" r:id="rId18"/>
+    <p:sldId id="268" r:id="rId19"/>
   </p:sldIdLst>
   <p:sldSz cx="12191695" cy="6858000" type="screen4x3"/>
   <p:notesSz cx="6858000" cy="9144000"/>
@@ -3468,7 +3470,7 @@
         <p:spPr>
           <a:xfrm>
             <a:off x="0" y="0"/>
-            <a:ext cx="12191695" cy="960120"/>
+            <a:ext cx="12191695" cy="1170432"/>
           </a:xfrm>
           <a:prstGeom prst="rect">
             <a:avLst/>
@@ -3510,7 +3512,7 @@
         </p:nvSpPr>
         <p:spPr>
           <a:xfrm>
-            <a:off x="0" y="960120"/>
+            <a:off x="0" y="1170432"/>
             <a:ext cx="12191695" cy="41148"/>
           </a:xfrm>
           <a:prstGeom prst="rect">
@@ -3554,7 +3556,7 @@
         <p:spPr>
           <a:xfrm>
             <a:off x="457200" y="164592"/>
-            <a:ext cx="11277295" cy="502920"/>
+            <a:ext cx="11277295" cy="384048"/>
           </a:xfrm>
           <a:prstGeom prst="rect">
             <a:avLst/>
@@ -3574,20 +3576,225 @@
                 </a:solidFill>
                 <a:latin typeface="Calibri"/>
               </a:rPr>
-              <a:t>Para continuar (PI)</a:t>
-            </a:r>
-          </a:p>
-        </p:txBody>
-      </p:sp>
-      <p:sp>
-        <p:nvSpPr>
-          <p:cNvPr id="5" name="Rounded Rectangle 4"/>
+              <a:t>Del boceto a ExamLab (diagrama)</a:t>
+            </a:r>
+          </a:p>
+        </p:txBody>
+      </p:sp>
+      <p:sp>
+        <p:nvSpPr>
+          <p:cNvPr id="5" name="TextBox 4"/>
+          <p:cNvSpPr txBox="1"/>
+          <p:nvPr/>
+        </p:nvSpPr>
+        <p:spPr>
+          <a:xfrm>
+            <a:off x="457200" y="566928"/>
+            <a:ext cx="11277295" cy="411480"/>
+          </a:xfrm>
+          <a:prstGeom prst="rect">
+            <a:avLst/>
+          </a:prstGeom>
+          <a:noFill/>
+        </p:spPr>
+        <p:txBody>
+          <a:bodyPr wrap="square">
+            <a:spAutoFit/>
+          </a:bodyPr>
+          <a:lstStyle/>
+          <a:p>
+            <a:r>
+              <a:rPr sz="1400" b="0" i="0">
+                <a:solidFill>
+                  <a:srgbClr val="B8D8EE"/>
+                </a:solidFill>
+                <a:latin typeface="Calibri"/>
+              </a:rPr>
+              <a:t>El diagrama se entrega como código Mermaid dentro de ExamLab, no como imagen</a:t>
+            </a:r>
+          </a:p>
+        </p:txBody>
+      </p:sp>
+      <p:sp>
+        <p:nvSpPr>
+          <p:cNvPr id="6" name="Rounded Rectangle 5"/>
           <p:cNvSpPr/>
           <p:nvPr/>
         </p:nvSpPr>
         <p:spPr>
           <a:xfrm>
-            <a:off x="457200" y="1261872"/>
+            <a:off x="457200" y="1659636"/>
+            <a:ext cx="11277295" cy="1051560"/>
+          </a:xfrm>
+          <a:prstGeom prst="roundRect">
+            <a:avLst>
+              <a:gd name="adj" fmla="val 12000"/>
+            </a:avLst>
+          </a:prstGeom>
+          <a:solidFill>
+            <a:srgbClr val="F2F2F2"/>
+          </a:solidFill>
+          <a:ln>
+            <a:noFill/>
+          </a:ln>
+        </p:spPr>
+        <p:style>
+          <a:lnRef idx="1">
+            <a:schemeClr val="accent1"/>
+          </a:lnRef>
+          <a:fillRef idx="3">
+            <a:schemeClr val="accent1"/>
+          </a:fillRef>
+          <a:effectRef idx="2">
+            <a:schemeClr val="accent1"/>
+          </a:effectRef>
+          <a:fontRef idx="minor">
+            <a:schemeClr val="lt1"/>
+          </a:fontRef>
+        </p:style>
+        <p:txBody>
+          <a:bodyPr rtlCol="0" anchor="ctr"/>
+          <a:lstStyle/>
+          <a:p>
+            <a:pPr algn="ctr"/>
+          </a:p>
+        </p:txBody>
+      </p:sp>
+      <p:sp>
+        <p:nvSpPr>
+          <p:cNvPr id="7" name="Rounded Rectangle 6"/>
+          <p:cNvSpPr/>
+          <p:nvPr/>
+        </p:nvSpPr>
+        <p:spPr>
+          <a:xfrm>
+            <a:off x="594360" y="1965960"/>
+            <a:ext cx="438912" cy="438912"/>
+          </a:xfrm>
+          <a:prstGeom prst="roundRect">
+            <a:avLst>
+              <a:gd name="adj" fmla="val 12000"/>
+            </a:avLst>
+          </a:prstGeom>
+          <a:solidFill>
+            <a:srgbClr val="095292"/>
+          </a:solidFill>
+          <a:ln>
+            <a:noFill/>
+          </a:ln>
+        </p:spPr>
+        <p:style>
+          <a:lnRef idx="1">
+            <a:schemeClr val="accent1"/>
+          </a:lnRef>
+          <a:fillRef idx="3">
+            <a:schemeClr val="accent1"/>
+          </a:fillRef>
+          <a:effectRef idx="2">
+            <a:schemeClr val="accent1"/>
+          </a:effectRef>
+          <a:fontRef idx="minor">
+            <a:schemeClr val="lt1"/>
+          </a:fontRef>
+        </p:style>
+        <p:txBody>
+          <a:bodyPr rtlCol="0" anchor="ctr"/>
+          <a:lstStyle/>
+          <a:p>
+            <a:pPr algn="ctr"/>
+          </a:p>
+        </p:txBody>
+      </p:sp>
+      <p:sp>
+        <p:nvSpPr>
+          <p:cNvPr id="8" name="TextBox 7"/>
+          <p:cNvSpPr txBox="1"/>
+          <p:nvPr/>
+        </p:nvSpPr>
+        <p:spPr>
+          <a:xfrm>
+            <a:off x="594360" y="1965960"/>
+            <a:ext cx="438912" cy="438912"/>
+          </a:xfrm>
+          <a:prstGeom prst="rect">
+            <a:avLst/>
+          </a:prstGeom>
+          <a:noFill/>
+        </p:spPr>
+        <p:txBody>
+          <a:bodyPr wrap="square" anchor="ctr"/>
+          <a:lstStyle/>
+          <a:p>
+            <a:pPr algn="ctr"/>
+            <a:r>
+              <a:rPr sz="1600" b="1" i="0">
+                <a:solidFill>
+                  <a:srgbClr val="FFFFFF"/>
+                </a:solidFill>
+                <a:latin typeface="Calibri"/>
+              </a:rPr>
+              <a:t>1</a:t>
+            </a:r>
+          </a:p>
+        </p:txBody>
+      </p:sp>
+      <p:sp>
+        <p:nvSpPr>
+          <p:cNvPr id="9" name="TextBox 8"/>
+          <p:cNvSpPr txBox="1"/>
+          <p:nvPr/>
+        </p:nvSpPr>
+        <p:spPr>
+          <a:xfrm>
+            <a:off x="1188720" y="1751076"/>
+            <a:ext cx="10271455" cy="886968"/>
+          </a:xfrm>
+          <a:prstGeom prst="rect">
+            <a:avLst/>
+          </a:prstGeom>
+          <a:noFill/>
+        </p:spPr>
+        <p:txBody>
+          <a:bodyPr wrap="square" anchor="ctr"/>
+          <a:lstStyle/>
+          <a:p>
+            <a:r>
+              <a:rPr sz="1500" b="1" i="0">
+                <a:solidFill>
+                  <a:srgbClr val="095292"/>
+                </a:solidFill>
+                <a:latin typeface="Calibri"/>
+              </a:rPr>
+              <a:t>Disena visual</a:t>
+            </a:r>
+          </a:p>
+          <a:p>
+            <a:pPr>
+              <a:spcBef>
+                <a:spcPts val="200"/>
+              </a:spcBef>
+            </a:pPr>
+            <a:r>
+              <a:rPr sz="1300" b="0" i="0">
+                <a:solidFill>
+                  <a:srgbClr val="333333"/>
+                </a:solidFill>
+                <a:latin typeface="Calibri"/>
+              </a:rPr>
+              <a:t>Dibuja el diagrama como quieras en Excalidraw o draw.io: es mas rapido arrastrar cajas que escribir codigo, y ahi es donde piensas el modelo.</a:t>
+            </a:r>
+          </a:p>
+        </p:txBody>
+      </p:sp>
+      <p:sp>
+        <p:nvSpPr>
+          <p:cNvPr id="10" name="Rounded Rectangle 9"/>
+          <p:cNvSpPr/>
+          <p:nvPr/>
+        </p:nvSpPr>
+        <p:spPr>
+          <a:xfrm>
+            <a:off x="457200" y="2802636"/>
             <a:ext cx="11277295" cy="1051560"/>
           </a:xfrm>
           <a:prstGeom prst="roundRect">
@@ -3626,20 +3833,22 @@
       </p:sp>
       <p:sp>
         <p:nvSpPr>
-          <p:cNvPr id="6" name="Rectangle 5"/>
+          <p:cNvPr id="11" name="Rounded Rectangle 10"/>
           <p:cNvSpPr/>
           <p:nvPr/>
         </p:nvSpPr>
         <p:spPr>
           <a:xfrm>
-            <a:off x="457200" y="1261872"/>
-            <a:ext cx="128016" cy="1051560"/>
-          </a:xfrm>
-          <a:prstGeom prst="rect">
-            <a:avLst/>
+            <a:off x="594360" y="3108960"/>
+            <a:ext cx="438912" cy="438912"/>
+          </a:xfrm>
+          <a:prstGeom prst="roundRect">
+            <a:avLst>
+              <a:gd name="adj" fmla="val 12000"/>
+            </a:avLst>
           </a:prstGeom>
           <a:solidFill>
-            <a:srgbClr val="269CCB"/>
+            <a:srgbClr val="095292"/>
           </a:solidFill>
           <a:ln>
             <a:noFill/>
@@ -3669,14 +3878,14 @@
       </p:sp>
       <p:sp>
         <p:nvSpPr>
-          <p:cNvPr id="7" name="TextBox 6"/>
+          <p:cNvPr id="12" name="TextBox 11"/>
           <p:cNvSpPr txBox="1"/>
           <p:nvPr/>
         </p:nvSpPr>
         <p:spPr>
           <a:xfrm>
-            <a:off x="777240" y="1399031"/>
-            <a:ext cx="10774375" cy="822959"/>
+            <a:off x="594360" y="3108960"/>
+            <a:ext cx="438912" cy="438912"/>
           </a:xfrm>
           <a:prstGeom prst="rect">
             <a:avLst/>
@@ -3684,48 +3893,79 @@
           <a:noFill/>
         </p:spPr>
         <p:txBody>
-          <a:bodyPr wrap="square">
-            <a:spAutoFit/>
-          </a:bodyPr>
-          <a:lstStyle/>
-          <a:p>
-            <a:r>
-              <a:rPr sz="1200" b="1" i="0">
-                <a:solidFill>
-                  <a:srgbClr val="269CCB"/>
-                </a:solidFill>
-                <a:latin typeface="Calibri"/>
-              </a:rPr>
-              <a:t>Info</a:t>
+          <a:bodyPr wrap="square" anchor="ctr"/>
+          <a:lstStyle/>
+          <a:p>
+            <a:pPr algn="ctr"/>
+            <a:r>
+              <a:rPr sz="1600" b="1" i="0">
+                <a:solidFill>
+                  <a:srgbClr val="FFFFFF"/>
+                </a:solidFill>
+                <a:latin typeface="Calibri"/>
+              </a:rPr>
+              <a:t>2</a:t>
+            </a:r>
+          </a:p>
+        </p:txBody>
+      </p:sp>
+      <p:sp>
+        <p:nvSpPr>
+          <p:cNvPr id="13" name="TextBox 12"/>
+          <p:cNvSpPr txBox="1"/>
+          <p:nvPr/>
+        </p:nvSpPr>
+        <p:spPr>
+          <a:xfrm>
+            <a:off x="1188720" y="2894076"/>
+            <a:ext cx="10271455" cy="886968"/>
+          </a:xfrm>
+          <a:prstGeom prst="rect">
+            <a:avLst/>
+          </a:prstGeom>
+          <a:noFill/>
+        </p:spPr>
+        <p:txBody>
+          <a:bodyPr wrap="square" anchor="ctr"/>
+          <a:lstStyle/>
+          <a:p>
+            <a:r>
+              <a:rPr sz="1500" b="1" i="0">
+                <a:solidFill>
+                  <a:srgbClr val="095292"/>
+                </a:solidFill>
+                <a:latin typeface="Calibri"/>
+              </a:rPr>
+              <a:t>Traduce con IA</a:t>
             </a:r>
           </a:p>
           <a:p>
             <a:pPr>
               <a:spcBef>
-                <a:spcPts val="400"/>
+                <a:spcPts val="200"/>
               </a:spcBef>
             </a:pPr>
             <a:r>
-              <a:rPr sz="1400" b="0" i="0">
+              <a:rPr sz="1300" b="0" i="0">
                 <a:solidFill>
                   <a:srgbClr val="333333"/>
                 </a:solidFill>
                 <a:latin typeface="Calibri"/>
               </a:rPr>
-              <a:t>Entregable: Ficha PI: dominio, capacidades, actores y boceto C4 Context (Excalidraw/draw.io)</a:t>
-            </a:r>
-          </a:p>
-        </p:txBody>
-      </p:sp>
-      <p:sp>
-        <p:nvSpPr>
-          <p:cNvPr id="8" name="Rounded Rectangle 7"/>
+              <a:t>Copia o describe tu boceto a una IA y pidele el codigo Mermaid: «convierte este diagrama a Mermaid usando C4Context». Revisa el resultado: la IA acierta la sintaxis, no tu modelo.</a:t>
+            </a:r>
+          </a:p>
+        </p:txBody>
+      </p:sp>
+      <p:sp>
+        <p:nvSpPr>
+          <p:cNvPr id="14" name="Rounded Rectangle 13"/>
           <p:cNvSpPr/>
           <p:nvPr/>
         </p:nvSpPr>
         <p:spPr>
           <a:xfrm>
-            <a:off x="457200" y="2478024"/>
+            <a:off x="457200" y="3945636"/>
             <a:ext cx="11277295" cy="1051560"/>
           </a:xfrm>
           <a:prstGeom prst="roundRect">
@@ -3734,7 +3974,7 @@
             </a:avLst>
           </a:prstGeom>
           <a:solidFill>
-            <a:srgbClr val="FFF8E1"/>
+            <a:srgbClr val="F2F2F2"/>
           </a:solidFill>
           <a:ln>
             <a:noFill/>
@@ -3764,20 +4004,22 @@
       </p:sp>
       <p:sp>
         <p:nvSpPr>
-          <p:cNvPr id="9" name="Rectangle 8"/>
+          <p:cNvPr id="15" name="Rounded Rectangle 14"/>
           <p:cNvSpPr/>
           <p:nvPr/>
         </p:nvSpPr>
         <p:spPr>
           <a:xfrm>
-            <a:off x="457200" y="2478024"/>
-            <a:ext cx="128016" cy="1051560"/>
-          </a:xfrm>
-          <a:prstGeom prst="rect">
-            <a:avLst/>
+            <a:off x="594360" y="4251960"/>
+            <a:ext cx="438912" cy="438912"/>
+          </a:xfrm>
+          <a:prstGeom prst="roundRect">
+            <a:avLst>
+              <a:gd name="adj" fmla="val 12000"/>
+            </a:avLst>
           </a:prstGeom>
           <a:solidFill>
-            <a:srgbClr val="FFD000"/>
+            <a:srgbClr val="095292"/>
           </a:solidFill>
           <a:ln>
             <a:noFill/>
@@ -3807,14 +4049,14 @@
       </p:sp>
       <p:sp>
         <p:nvSpPr>
-          <p:cNvPr id="10" name="TextBox 9"/>
+          <p:cNvPr id="16" name="TextBox 15"/>
           <p:cNvSpPr txBox="1"/>
           <p:nvPr/>
         </p:nvSpPr>
         <p:spPr>
           <a:xfrm>
-            <a:off x="777240" y="2615184"/>
-            <a:ext cx="10774375" cy="822959"/>
+            <a:off x="594360" y="4251960"/>
+            <a:ext cx="438912" cy="438912"/>
           </a:xfrm>
           <a:prstGeom prst="rect">
             <a:avLst/>
@@ -3822,48 +4064,79 @@
           <a:noFill/>
         </p:spPr>
         <p:txBody>
-          <a:bodyPr wrap="square">
-            <a:spAutoFit/>
-          </a:bodyPr>
-          <a:lstStyle/>
-          <a:p>
-            <a:r>
-              <a:rPr sz="1200" b="1" i="0">
-                <a:solidFill>
-                  <a:srgbClr val="FFD000"/>
-                </a:solidFill>
-                <a:latin typeface="Calibri"/>
-              </a:rPr>
-              <a:t>Aclaración</a:t>
+          <a:bodyPr wrap="square" anchor="ctr"/>
+          <a:lstStyle/>
+          <a:p>
+            <a:pPr algn="ctr"/>
+            <a:r>
+              <a:rPr sz="1600" b="1" i="0">
+                <a:solidFill>
+                  <a:srgbClr val="FFFFFF"/>
+                </a:solidFill>
+                <a:latin typeface="Calibri"/>
+              </a:rPr>
+              <a:t>3</a:t>
+            </a:r>
+          </a:p>
+        </p:txBody>
+      </p:sp>
+      <p:sp>
+        <p:nvSpPr>
+          <p:cNvPr id="17" name="TextBox 16"/>
+          <p:cNvSpPr txBox="1"/>
+          <p:nvPr/>
+        </p:nvSpPr>
+        <p:spPr>
+          <a:xfrm>
+            <a:off x="1188720" y="4037076"/>
+            <a:ext cx="10271455" cy="886968"/>
+          </a:xfrm>
+          <a:prstGeom prst="rect">
+            <a:avLst/>
+          </a:prstGeom>
+          <a:noFill/>
+        </p:spPr>
+        <p:txBody>
+          <a:bodyPr wrap="square" anchor="ctr"/>
+          <a:lstStyle/>
+          <a:p>
+            <a:r>
+              <a:rPr sz="1500" b="1" i="0">
+                <a:solidFill>
+                  <a:srgbClr val="095292"/>
+                </a:solidFill>
+                <a:latin typeface="Calibri"/>
+              </a:rPr>
+              <a:t>Pega y renderiza en ExamLab</a:t>
             </a:r>
           </a:p>
           <a:p>
             <a:pPr>
               <a:spcBef>
-                <a:spcPts val="400"/>
+                <a:spcPts val="200"/>
               </a:spcBef>
             </a:pPr>
             <a:r>
-              <a:rPr sz="1400" b="0" i="0">
+              <a:rPr sz="1300" b="0" i="0">
                 <a:solidFill>
                   <a:srgbClr val="333333"/>
                 </a:solidFill>
                 <a:latin typeface="Calibri"/>
               </a:rPr>
-              <a:t>Subir evidencias al paquete CloudLite (Drive/repo) y a ExamLab (https://uniaj.examlab.workers.dev/) domingo 23:59.</a:t>
-            </a:r>
-          </a:p>
-        </p:txBody>
-      </p:sp>
-      <p:sp>
-        <p:nvSpPr>
-          <p:cNvPr id="11" name="Rounded Rectangle 10"/>
+              <a:t>Pega ese codigo en la caja de texto de la pregunta y mira como lo dibuja la plataforma. Si no renderiza, corrige ahi mismo: lo que se califica es el diagrama renderizado dentro de ExamLab.</a:t>
+            </a:r>
+          </a:p>
+        </p:txBody>
+      </p:sp>
+      <p:sp>
+        <p:nvSpPr>
+          <p:cNvPr id="18" name="Rounded Rectangle 17"/>
           <p:cNvSpPr/>
           <p:nvPr/>
         </p:nvSpPr>
         <p:spPr>
           <a:xfrm>
-            <a:off x="457200" y="3694176"/>
+            <a:off x="457200" y="5088636"/>
             <a:ext cx="11277295" cy="1051560"/>
           </a:xfrm>
           <a:prstGeom prst="roundRect">
@@ -3872,7 +4145,7 @@
             </a:avLst>
           </a:prstGeom>
           <a:solidFill>
-            <a:srgbClr val="FBE4E4"/>
+            <a:srgbClr val="E8F4FA"/>
           </a:solidFill>
           <a:ln>
             <a:noFill/>
@@ -3902,20 +4175,22 @@
       </p:sp>
       <p:sp>
         <p:nvSpPr>
-          <p:cNvPr id="12" name="Rectangle 11"/>
+          <p:cNvPr id="19" name="Rounded Rectangle 18"/>
           <p:cNvSpPr/>
           <p:nvPr/>
         </p:nvSpPr>
         <p:spPr>
           <a:xfrm>
-            <a:off x="457200" y="3694176"/>
-            <a:ext cx="128016" cy="1051560"/>
-          </a:xfrm>
-          <a:prstGeom prst="rect">
-            <a:avLst/>
+            <a:off x="594360" y="5394960"/>
+            <a:ext cx="438912" cy="438912"/>
+          </a:xfrm>
+          <a:prstGeom prst="roundRect">
+            <a:avLst>
+              <a:gd name="adj" fmla="val 12000"/>
+            </a:avLst>
           </a:prstGeom>
           <a:solidFill>
-            <a:srgbClr val="A02030"/>
+            <a:srgbClr val="095292"/>
           </a:solidFill>
           <a:ln>
             <a:noFill/>
@@ -3945,14 +4220,14 @@
       </p:sp>
       <p:sp>
         <p:nvSpPr>
-          <p:cNvPr id="13" name="TextBox 12"/>
+          <p:cNvPr id="20" name="TextBox 19"/>
           <p:cNvSpPr txBox="1"/>
           <p:nvPr/>
         </p:nvSpPr>
         <p:spPr>
           <a:xfrm>
-            <a:off x="777240" y="3831336"/>
-            <a:ext cx="10774375" cy="822959"/>
+            <a:off x="594360" y="5394960"/>
+            <a:ext cx="438912" cy="438912"/>
           </a:xfrm>
           <a:prstGeom prst="rect">
             <a:avLst/>
@@ -3960,42 +4235,73 @@
           <a:noFill/>
         </p:spPr>
         <p:txBody>
-          <a:bodyPr wrap="square">
-            <a:spAutoFit/>
-          </a:bodyPr>
-          <a:lstStyle/>
-          <a:p>
-            <a:r>
-              <a:rPr sz="1200" b="1" i="0">
-                <a:solidFill>
-                  <a:srgbClr val="A02030"/>
-                </a:solidFill>
-                <a:latin typeface="Calibri"/>
-              </a:rPr>
-              <a:t>Atención</a:t>
+          <a:bodyPr wrap="square" anchor="ctr"/>
+          <a:lstStyle/>
+          <a:p>
+            <a:pPr algn="ctr"/>
+            <a:r>
+              <a:rPr sz="1600" b="1" i="0">
+                <a:solidFill>
+                  <a:srgbClr val="FFFFFF"/>
+                </a:solidFill>
+                <a:latin typeface="Calibri"/>
+              </a:rPr>
+              <a:t>4</a:t>
+            </a:r>
+          </a:p>
+        </p:txBody>
+      </p:sp>
+      <p:sp>
+        <p:nvSpPr>
+          <p:cNvPr id="21" name="TextBox 20"/>
+          <p:cNvSpPr txBox="1"/>
+          <p:nvPr/>
+        </p:nvSpPr>
+        <p:spPr>
+          <a:xfrm>
+            <a:off x="1188720" y="5180076"/>
+            <a:ext cx="10271455" cy="886968"/>
+          </a:xfrm>
+          <a:prstGeom prst="rect">
+            <a:avLst/>
+          </a:prstGeom>
+          <a:noFill/>
+        </p:spPr>
+        <p:txBody>
+          <a:bodyPr wrap="square" anchor="ctr"/>
+          <a:lstStyle/>
+          <a:p>
+            <a:r>
+              <a:rPr sz="1500" b="1" i="0">
+                <a:solidFill>
+                  <a:srgbClr val="095292"/>
+                </a:solidFill>
+                <a:latin typeface="Calibri"/>
+              </a:rPr>
+              <a:t>Guarda el PNG para tu PI</a:t>
             </a:r>
           </a:p>
           <a:p>
             <a:pPr>
               <a:spcBef>
-                <a:spcPts val="400"/>
+                <a:spcPts val="200"/>
               </a:spcBef>
             </a:pPr>
             <a:r>
-              <a:rPr sz="1400" b="0" i="0">
+              <a:rPr sz="1300" b="0" i="0">
                 <a:solidFill>
                   <a:srgbClr val="333333"/>
                 </a:solidFill>
                 <a:latin typeface="Calibri"/>
               </a:rPr>
-              <a:t>Sin cloud de pago ni instalaciones obligatorias de hipervisores/Docker Desktop.</a:t>
-            </a:r>
-          </a:p>
-        </p:txBody>
-      </p:sp>
-      <p:sp>
-        <p:nvSpPr>
-          <p:cNvPr id="14" name="TextBox 13"/>
+              <a:t>Exporta tambien la imagen a la carpeta de tu Proyecto Integrador. Esa copia es para tu informe; no reemplaza la respuesta en la plataforma.</a:t>
+            </a:r>
+          </a:p>
+        </p:txBody>
+      </p:sp>
+      <p:sp>
+        <p:nvSpPr>
+          <p:cNvPr id="22" name="TextBox 21"/>
           <p:cNvSpPr txBox="1"/>
           <p:nvPr/>
         </p:nvSpPr>
@@ -4063,6 +4369,932 @@
         <p:spPr>
           <a:xfrm>
             <a:off x="0" y="0"/>
+            <a:ext cx="12191695" cy="960120"/>
+          </a:xfrm>
+          <a:prstGeom prst="rect">
+            <a:avLst/>
+          </a:prstGeom>
+          <a:solidFill>
+            <a:srgbClr val="095292"/>
+          </a:solidFill>
+          <a:ln>
+            <a:noFill/>
+          </a:ln>
+        </p:spPr>
+        <p:style>
+          <a:lnRef idx="1">
+            <a:schemeClr val="accent1"/>
+          </a:lnRef>
+          <a:fillRef idx="3">
+            <a:schemeClr val="accent1"/>
+          </a:fillRef>
+          <a:effectRef idx="2">
+            <a:schemeClr val="accent1"/>
+          </a:effectRef>
+          <a:fontRef idx="minor">
+            <a:schemeClr val="lt1"/>
+          </a:fontRef>
+        </p:style>
+        <p:txBody>
+          <a:bodyPr rtlCol="0" anchor="ctr"/>
+          <a:lstStyle/>
+          <a:p>
+            <a:pPr algn="ctr"/>
+          </a:p>
+        </p:txBody>
+      </p:sp>
+      <p:sp>
+        <p:nvSpPr>
+          <p:cNvPr id="3" name="Rectangle 2"/>
+          <p:cNvSpPr/>
+          <p:nvPr/>
+        </p:nvSpPr>
+        <p:spPr>
+          <a:xfrm>
+            <a:off x="0" y="960120"/>
+            <a:ext cx="12191695" cy="41148"/>
+          </a:xfrm>
+          <a:prstGeom prst="rect">
+            <a:avLst/>
+          </a:prstGeom>
+          <a:solidFill>
+            <a:srgbClr val="FFD000"/>
+          </a:solidFill>
+          <a:ln>
+            <a:noFill/>
+          </a:ln>
+        </p:spPr>
+        <p:style>
+          <a:lnRef idx="1">
+            <a:schemeClr val="accent1"/>
+          </a:lnRef>
+          <a:fillRef idx="3">
+            <a:schemeClr val="accent1"/>
+          </a:fillRef>
+          <a:effectRef idx="2">
+            <a:schemeClr val="accent1"/>
+          </a:effectRef>
+          <a:fontRef idx="minor">
+            <a:schemeClr val="lt1"/>
+          </a:fontRef>
+        </p:style>
+        <p:txBody>
+          <a:bodyPr rtlCol="0" anchor="ctr"/>
+          <a:lstStyle/>
+          <a:p>
+            <a:pPr algn="ctr"/>
+          </a:p>
+        </p:txBody>
+      </p:sp>
+      <p:sp>
+        <p:nvSpPr>
+          <p:cNvPr id="4" name="TextBox 3"/>
+          <p:cNvSpPr txBox="1"/>
+          <p:nvPr/>
+        </p:nvSpPr>
+        <p:spPr>
+          <a:xfrm>
+            <a:off x="457200" y="164592"/>
+            <a:ext cx="11277295" cy="502920"/>
+          </a:xfrm>
+          <a:prstGeom prst="rect">
+            <a:avLst/>
+          </a:prstGeom>
+          <a:noFill/>
+        </p:spPr>
+        <p:txBody>
+          <a:bodyPr wrap="square">
+            <a:spAutoFit/>
+          </a:bodyPr>
+          <a:lstStyle/>
+          <a:p>
+            <a:r>
+              <a:rPr sz="2600" b="1" i="0">
+                <a:solidFill>
+                  <a:srgbClr val="FFFFFF"/>
+                </a:solidFill>
+                <a:latin typeface="Calibri"/>
+              </a:rPr>
+              <a:t>Taller PI (paso a paso)</a:t>
+            </a:r>
+          </a:p>
+        </p:txBody>
+      </p:sp>
+      <p:sp>
+        <p:nvSpPr>
+          <p:cNvPr id="5" name="TextBox 4"/>
+          <p:cNvSpPr txBox="1"/>
+          <p:nvPr/>
+        </p:nvSpPr>
+        <p:spPr>
+          <a:xfrm>
+            <a:off x="457200" y="1170432"/>
+            <a:ext cx="11277295" cy="5230368"/>
+          </a:xfrm>
+          <a:prstGeom prst="rect">
+            <a:avLst/>
+          </a:prstGeom>
+          <a:noFill/>
+        </p:spPr>
+        <p:txBody>
+          <a:bodyPr wrap="square">
+            <a:spAutoFit/>
+          </a:bodyPr>
+          <a:lstStyle/>
+          <a:p>
+            <a:pPr>
+              <a:spcAft>
+                <a:spcPts val="800"/>
+              </a:spcAft>
+            </a:pPr>
+            <a:r>
+              <a:rPr sz="1600" b="1" i="0">
+                <a:solidFill>
+                  <a:srgbClr val="333333"/>
+                </a:solidFill>
+                <a:latin typeface="Calibri"/>
+              </a:rPr>
+              <a:t>1.</a:t>
+            </a:r>
+            <a:r>
+              <a:rPr sz="1600" b="0" i="0">
+                <a:solidFill>
+                  <a:srgbClr val="333333"/>
+                </a:solidFill>
+                <a:latin typeface="Calibri"/>
+              </a:rPr>
+              <a:t> Paso 1: elija un dominio concreto entre AgendaU, BiblioLite, InventarioLab, TurnosClinica o EventosCampus (o uno propio del mismo tamano) y escriba el problema en exactamente 3 frases: quien sufre el problema, como se resuelve hoy sin CloudLite y una cifra medible del dolor (por ejemplo 40 correos por semana para cuadrar 12 asesorias), verificando que en ninguna de las 3 frases aparezca una expresion generica como app de la universidad o red social; el resultado queda en la seccion 1 Dominio y problema del informe del PI.</a:t>
+            </a:r>
+          </a:p>
+          <a:p>
+            <a:pPr>
+              <a:spcAft>
+                <a:spcPts val="800"/>
+              </a:spcAft>
+            </a:pPr>
+            <a:r>
+              <a:rPr sz="1600" b="0" i="0">
+                <a:solidFill>
+                  <a:srgbClr val="333333"/>
+                </a:solidFill>
+                <a:latin typeface="Calibri"/>
+              </a:rPr>
+              <a:t>–   </a:t>
+            </a:r>
+            <a:r>
+              <a:rPr sz="1600" b="1" i="0">
+                <a:solidFill>
+                  <a:srgbClr val="333333"/>
+                </a:solidFill>
+                <a:latin typeface="Calibri"/>
+              </a:rPr>
+              <a:t>2.</a:t>
+            </a:r>
+            <a:r>
+              <a:rPr sz="1600" b="0" i="0">
+                <a:solidFill>
+                  <a:srgbClr val="333333"/>
+                </a:solidFill>
+                <a:latin typeface="Calibri"/>
+              </a:rPr>
+              <a:t> Paso 2: liste exactamente 4 capacidades con la forma verbo mas objeto de negocio (reservar cita, publicar cupo, cancelar reserva, notificar recordatorio), 3 actores humanos con lo que espera cada uno, 2 o 3 sistemas externos con los que CloudLite intercambia informacion (por ejemplo proveedor de identidad, correo transaccional o pasarela de pagos) y 3 elementos de fuera de alcance, verificando que ninguna capacidad nombre tecnologia (nada de usar PostgreSQL ni desplegar en Docker) y que las 4 capacidades se lean como frases del negocio; queda en la seccion 1 del informe y se pega tal cual en la pregunta 1 de ExamLab.</a:t>
+            </a:r>
+          </a:p>
+          <a:p>
+            <a:pPr>
+              <a:spcAft>
+                <a:spcPts val="800"/>
+              </a:spcAft>
+            </a:pPr>
+            <a:r>
+              <a:rPr sz="1600" b="0" i="0">
+                <a:solidFill>
+                  <a:srgbClr val="333333"/>
+                </a:solidFill>
+                <a:latin typeface="Calibri"/>
+              </a:rPr>
+              <a:t>–   </a:t>
+            </a:r>
+            <a:r>
+              <a:rPr sz="1600" b="1" i="0">
+                <a:solidFill>
+                  <a:srgbClr val="333333"/>
+                </a:solidFill>
+                <a:latin typeface="Calibri"/>
+              </a:rPr>
+              <a:t>3.</a:t>
+            </a:r>
+            <a:r>
+              <a:rPr sz="1600" b="0" i="0">
+                <a:solidFill>
+                  <a:srgbClr val="333333"/>
+                </a:solidFill>
+                <a:latin typeface="Calibri"/>
+              </a:rPr>
+              <a:t> Paso 3: dibuje primero el boceto del C4 Context en Excalidraw o draw.io, que es donde se piensa el modelo, y despues pidale a una IA que lo traduzca a Mermaid («convierte este diagrama a Mermaid usando C4Context»); pegue ese codigo en la pregunta de tipo diagrama de ExamLab y verifique que renderice ahi mismo, con exactamente 1 System para CloudLite, 2 Person, 2 System_Ext y 5 relaciones etiquetadas con verbo de negocio y protocolo, verificando en el diagrama ya renderizado que no aparezca ninguna caja interna (ni base de datos ni API ni worker, eso es Clase 4) y que cada flecha se lea en voz alta como una frase completa.</a:t>
+            </a:r>
+          </a:p>
+          <a:p>
+            <a:pPr>
+              <a:spcAft>
+                <a:spcPts val="800"/>
+              </a:spcAft>
+            </a:pPr>
+            <a:r>
+              <a:rPr sz="1600" b="0" i="0">
+                <a:solidFill>
+                  <a:srgbClr val="333333"/>
+                </a:solidFill>
+                <a:latin typeface="Calibri"/>
+              </a:rPr>
+              <a:t>–   </a:t>
+            </a:r>
+            <a:r>
+              <a:rPr sz="1600" b="1" i="0">
+                <a:solidFill>
+                  <a:srgbClr val="333333"/>
+                </a:solidFill>
+                <a:latin typeface="Calibri"/>
+              </a:rPr>
+              <a:t>4.</a:t>
+            </a:r>
+            <a:r>
+              <a:rPr sz="1600" b="0" i="0">
+                <a:solidFill>
+                  <a:srgbClr val="333333"/>
+                </a:solidFill>
+                <a:latin typeface="Calibri"/>
+              </a:rPr>
+              <a:t> Paso 4: resuelva la tabla comparativa de 4 filas nube frente a on-premise, cierre con el veredicto de 2 frases que sera la entrada del ADR-001 de la Clase 2, y suba a ExamLab (modulo Talleres) las 5 preguntas resueltas antes del domingo 23:59, verificando que la ficha, el diagrama renderizado y el veredicto usen exactamente los mismos nombres de actores y de sistemas externos.</a:t>
+            </a:r>
+          </a:p>
+        </p:txBody>
+      </p:sp>
+      <p:sp>
+        <p:nvSpPr>
+          <p:cNvPr id="6" name="TextBox 5"/>
+          <p:cNvSpPr txBox="1"/>
+          <p:nvPr/>
+        </p:nvSpPr>
+        <p:spPr>
+          <a:xfrm>
+            <a:off x="11185855" y="6473952"/>
+            <a:ext cx="640080" cy="274320"/>
+          </a:xfrm>
+          <a:prstGeom prst="rect">
+            <a:avLst/>
+          </a:prstGeom>
+          <a:noFill/>
+        </p:spPr>
+        <p:txBody>
+          <a:bodyPr wrap="square">
+            <a:spAutoFit/>
+          </a:bodyPr>
+          <a:lstStyle/>
+          <a:p>
+            <a:pPr algn="r"/>
+            <a:r>
+              <a:rPr sz="1100" b="0" i="0">
+                <a:solidFill>
+                  <a:srgbClr val="666666"/>
+                </a:solidFill>
+                <a:latin typeface="Calibri"/>
+              </a:rPr>
+              <a:t>11</a:t>
+            </a:r>
+          </a:p>
+        </p:txBody>
+      </p:sp>
+    </p:spTree>
+  </p:cSld>
+  <p:clrMapOvr>
+    <a:masterClrMapping/>
+  </p:clrMapOvr>
+</p:sld>
+</file>
+
+<file path=ppt/slides/slide12.xml><?xml version="1.0" encoding="utf-8"?>
+<p:sld xmlns:a="http://schemas.openxmlformats.org/drawingml/2006/main" xmlns:p="http://schemas.openxmlformats.org/presentationml/2006/main" xmlns:r="http://schemas.openxmlformats.org/officeDocument/2006/relationships">
+  <p:cSld>
+    <p:bg>
+      <p:bgPr>
+        <a:solidFill>
+          <a:srgbClr val="FFFFFF"/>
+        </a:solidFill>
+        <a:effectLst/>
+      </p:bgPr>
+    </p:bg>
+    <p:spTree>
+      <p:nvGrpSpPr>
+        <p:cNvPr id="1" name=""/>
+        <p:cNvGrpSpPr/>
+        <p:nvPr/>
+      </p:nvGrpSpPr>
+      <p:grpSpPr/>
+      <p:sp>
+        <p:nvSpPr>
+          <p:cNvPr id="2" name="Rectangle 1"/>
+          <p:cNvSpPr/>
+          <p:nvPr/>
+        </p:nvSpPr>
+        <p:spPr>
+          <a:xfrm>
+            <a:off x="0" y="0"/>
+            <a:ext cx="12191695" cy="960120"/>
+          </a:xfrm>
+          <a:prstGeom prst="rect">
+            <a:avLst/>
+          </a:prstGeom>
+          <a:solidFill>
+            <a:srgbClr val="095292"/>
+          </a:solidFill>
+          <a:ln>
+            <a:noFill/>
+          </a:ln>
+        </p:spPr>
+        <p:style>
+          <a:lnRef idx="1">
+            <a:schemeClr val="accent1"/>
+          </a:lnRef>
+          <a:fillRef idx="3">
+            <a:schemeClr val="accent1"/>
+          </a:fillRef>
+          <a:effectRef idx="2">
+            <a:schemeClr val="accent1"/>
+          </a:effectRef>
+          <a:fontRef idx="minor">
+            <a:schemeClr val="lt1"/>
+          </a:fontRef>
+        </p:style>
+        <p:txBody>
+          <a:bodyPr rtlCol="0" anchor="ctr"/>
+          <a:lstStyle/>
+          <a:p>
+            <a:pPr algn="ctr"/>
+          </a:p>
+        </p:txBody>
+      </p:sp>
+      <p:sp>
+        <p:nvSpPr>
+          <p:cNvPr id="3" name="Rectangle 2"/>
+          <p:cNvSpPr/>
+          <p:nvPr/>
+        </p:nvSpPr>
+        <p:spPr>
+          <a:xfrm>
+            <a:off x="0" y="960120"/>
+            <a:ext cx="12191695" cy="41148"/>
+          </a:xfrm>
+          <a:prstGeom prst="rect">
+            <a:avLst/>
+          </a:prstGeom>
+          <a:solidFill>
+            <a:srgbClr val="FFD000"/>
+          </a:solidFill>
+          <a:ln>
+            <a:noFill/>
+          </a:ln>
+        </p:spPr>
+        <p:style>
+          <a:lnRef idx="1">
+            <a:schemeClr val="accent1"/>
+          </a:lnRef>
+          <a:fillRef idx="3">
+            <a:schemeClr val="accent1"/>
+          </a:fillRef>
+          <a:effectRef idx="2">
+            <a:schemeClr val="accent1"/>
+          </a:effectRef>
+          <a:fontRef idx="minor">
+            <a:schemeClr val="lt1"/>
+          </a:fontRef>
+        </p:style>
+        <p:txBody>
+          <a:bodyPr rtlCol="0" anchor="ctr"/>
+          <a:lstStyle/>
+          <a:p>
+            <a:pPr algn="ctr"/>
+          </a:p>
+        </p:txBody>
+      </p:sp>
+      <p:sp>
+        <p:nvSpPr>
+          <p:cNvPr id="4" name="TextBox 3"/>
+          <p:cNvSpPr txBox="1"/>
+          <p:nvPr/>
+        </p:nvSpPr>
+        <p:spPr>
+          <a:xfrm>
+            <a:off x="457200" y="164592"/>
+            <a:ext cx="11277295" cy="502920"/>
+          </a:xfrm>
+          <a:prstGeom prst="rect">
+            <a:avLst/>
+          </a:prstGeom>
+          <a:noFill/>
+        </p:spPr>
+        <p:txBody>
+          <a:bodyPr wrap="square">
+            <a:spAutoFit/>
+          </a:bodyPr>
+          <a:lstStyle/>
+          <a:p>
+            <a:r>
+              <a:rPr sz="2600" b="1" i="0">
+                <a:solidFill>
+                  <a:srgbClr val="FFFFFF"/>
+                </a:solidFill>
+                <a:latin typeface="Calibri"/>
+              </a:rPr>
+              <a:t>Para continuar (PI)</a:t>
+            </a:r>
+          </a:p>
+        </p:txBody>
+      </p:sp>
+      <p:sp>
+        <p:nvSpPr>
+          <p:cNvPr id="5" name="Rounded Rectangle 4"/>
+          <p:cNvSpPr/>
+          <p:nvPr/>
+        </p:nvSpPr>
+        <p:spPr>
+          <a:xfrm>
+            <a:off x="457200" y="1261872"/>
+            <a:ext cx="11277295" cy="1051560"/>
+          </a:xfrm>
+          <a:prstGeom prst="roundRect">
+            <a:avLst>
+              <a:gd name="adj" fmla="val 12000"/>
+            </a:avLst>
+          </a:prstGeom>
+          <a:solidFill>
+            <a:srgbClr val="E8F4FA"/>
+          </a:solidFill>
+          <a:ln>
+            <a:noFill/>
+          </a:ln>
+        </p:spPr>
+        <p:style>
+          <a:lnRef idx="1">
+            <a:schemeClr val="accent1"/>
+          </a:lnRef>
+          <a:fillRef idx="3">
+            <a:schemeClr val="accent1"/>
+          </a:fillRef>
+          <a:effectRef idx="2">
+            <a:schemeClr val="accent1"/>
+          </a:effectRef>
+          <a:fontRef idx="minor">
+            <a:schemeClr val="lt1"/>
+          </a:fontRef>
+        </p:style>
+        <p:txBody>
+          <a:bodyPr rtlCol="0" anchor="ctr"/>
+          <a:lstStyle/>
+          <a:p>
+            <a:pPr algn="ctr"/>
+          </a:p>
+        </p:txBody>
+      </p:sp>
+      <p:sp>
+        <p:nvSpPr>
+          <p:cNvPr id="6" name="Rectangle 5"/>
+          <p:cNvSpPr/>
+          <p:nvPr/>
+        </p:nvSpPr>
+        <p:spPr>
+          <a:xfrm>
+            <a:off x="457200" y="1261872"/>
+            <a:ext cx="128016" cy="1051560"/>
+          </a:xfrm>
+          <a:prstGeom prst="rect">
+            <a:avLst/>
+          </a:prstGeom>
+          <a:solidFill>
+            <a:srgbClr val="269CCB"/>
+          </a:solidFill>
+          <a:ln>
+            <a:noFill/>
+          </a:ln>
+        </p:spPr>
+        <p:style>
+          <a:lnRef idx="1">
+            <a:schemeClr val="accent1"/>
+          </a:lnRef>
+          <a:fillRef idx="3">
+            <a:schemeClr val="accent1"/>
+          </a:fillRef>
+          <a:effectRef idx="2">
+            <a:schemeClr val="accent1"/>
+          </a:effectRef>
+          <a:fontRef idx="minor">
+            <a:schemeClr val="lt1"/>
+          </a:fontRef>
+        </p:style>
+        <p:txBody>
+          <a:bodyPr rtlCol="0" anchor="ctr"/>
+          <a:lstStyle/>
+          <a:p>
+            <a:pPr algn="ctr"/>
+          </a:p>
+        </p:txBody>
+      </p:sp>
+      <p:sp>
+        <p:nvSpPr>
+          <p:cNvPr id="7" name="TextBox 6"/>
+          <p:cNvSpPr txBox="1"/>
+          <p:nvPr/>
+        </p:nvSpPr>
+        <p:spPr>
+          <a:xfrm>
+            <a:off x="777240" y="1399031"/>
+            <a:ext cx="10774375" cy="822959"/>
+          </a:xfrm>
+          <a:prstGeom prst="rect">
+            <a:avLst/>
+          </a:prstGeom>
+          <a:noFill/>
+        </p:spPr>
+        <p:txBody>
+          <a:bodyPr wrap="square">
+            <a:spAutoFit/>
+          </a:bodyPr>
+          <a:lstStyle/>
+          <a:p>
+            <a:r>
+              <a:rPr sz="1200" b="1" i="0">
+                <a:solidFill>
+                  <a:srgbClr val="269CCB"/>
+                </a:solidFill>
+                <a:latin typeface="Calibri"/>
+              </a:rPr>
+              <a:t>Info</a:t>
+            </a:r>
+          </a:p>
+          <a:p>
+            <a:pPr>
+              <a:spcBef>
+                <a:spcPts val="400"/>
+              </a:spcBef>
+            </a:pPr>
+            <a:r>
+              <a:rPr sz="1400" b="0" i="0">
+                <a:solidFill>
+                  <a:srgbClr val="333333"/>
+                </a:solidFill>
+                <a:latin typeface="Calibri"/>
+              </a:rPr>
+              <a:t>Entregable: Ficha PI de 6 bloques + C4 Context en Mermaid renderizado en ExamLab (boceto previo en Excalidraw/draw.io)</a:t>
+            </a:r>
+          </a:p>
+        </p:txBody>
+      </p:sp>
+      <p:sp>
+        <p:nvSpPr>
+          <p:cNvPr id="8" name="Rounded Rectangle 7"/>
+          <p:cNvSpPr/>
+          <p:nvPr/>
+        </p:nvSpPr>
+        <p:spPr>
+          <a:xfrm>
+            <a:off x="457200" y="2478024"/>
+            <a:ext cx="11277295" cy="1051560"/>
+          </a:xfrm>
+          <a:prstGeom prst="roundRect">
+            <a:avLst>
+              <a:gd name="adj" fmla="val 12000"/>
+            </a:avLst>
+          </a:prstGeom>
+          <a:solidFill>
+            <a:srgbClr val="FFF8E1"/>
+          </a:solidFill>
+          <a:ln>
+            <a:noFill/>
+          </a:ln>
+        </p:spPr>
+        <p:style>
+          <a:lnRef idx="1">
+            <a:schemeClr val="accent1"/>
+          </a:lnRef>
+          <a:fillRef idx="3">
+            <a:schemeClr val="accent1"/>
+          </a:fillRef>
+          <a:effectRef idx="2">
+            <a:schemeClr val="accent1"/>
+          </a:effectRef>
+          <a:fontRef idx="minor">
+            <a:schemeClr val="lt1"/>
+          </a:fontRef>
+        </p:style>
+        <p:txBody>
+          <a:bodyPr rtlCol="0" anchor="ctr"/>
+          <a:lstStyle/>
+          <a:p>
+            <a:pPr algn="ctr"/>
+          </a:p>
+        </p:txBody>
+      </p:sp>
+      <p:sp>
+        <p:nvSpPr>
+          <p:cNvPr id="9" name="Rectangle 8"/>
+          <p:cNvSpPr/>
+          <p:nvPr/>
+        </p:nvSpPr>
+        <p:spPr>
+          <a:xfrm>
+            <a:off x="457200" y="2478024"/>
+            <a:ext cx="128016" cy="1051560"/>
+          </a:xfrm>
+          <a:prstGeom prst="rect">
+            <a:avLst/>
+          </a:prstGeom>
+          <a:solidFill>
+            <a:srgbClr val="FFD000"/>
+          </a:solidFill>
+          <a:ln>
+            <a:noFill/>
+          </a:ln>
+        </p:spPr>
+        <p:style>
+          <a:lnRef idx="1">
+            <a:schemeClr val="accent1"/>
+          </a:lnRef>
+          <a:fillRef idx="3">
+            <a:schemeClr val="accent1"/>
+          </a:fillRef>
+          <a:effectRef idx="2">
+            <a:schemeClr val="accent1"/>
+          </a:effectRef>
+          <a:fontRef idx="minor">
+            <a:schemeClr val="lt1"/>
+          </a:fontRef>
+        </p:style>
+        <p:txBody>
+          <a:bodyPr rtlCol="0" anchor="ctr"/>
+          <a:lstStyle/>
+          <a:p>
+            <a:pPr algn="ctr"/>
+          </a:p>
+        </p:txBody>
+      </p:sp>
+      <p:sp>
+        <p:nvSpPr>
+          <p:cNvPr id="10" name="TextBox 9"/>
+          <p:cNvSpPr txBox="1"/>
+          <p:nvPr/>
+        </p:nvSpPr>
+        <p:spPr>
+          <a:xfrm>
+            <a:off x="777240" y="2615184"/>
+            <a:ext cx="10774375" cy="822959"/>
+          </a:xfrm>
+          <a:prstGeom prst="rect">
+            <a:avLst/>
+          </a:prstGeom>
+          <a:noFill/>
+        </p:spPr>
+        <p:txBody>
+          <a:bodyPr wrap="square">
+            <a:spAutoFit/>
+          </a:bodyPr>
+          <a:lstStyle/>
+          <a:p>
+            <a:r>
+              <a:rPr sz="1200" b="1" i="0">
+                <a:solidFill>
+                  <a:srgbClr val="FFD000"/>
+                </a:solidFill>
+                <a:latin typeface="Calibri"/>
+              </a:rPr>
+              <a:t>Aclaración</a:t>
+            </a:r>
+          </a:p>
+          <a:p>
+            <a:pPr>
+              <a:spcBef>
+                <a:spcPts val="400"/>
+              </a:spcBef>
+            </a:pPr>
+            <a:r>
+              <a:rPr sz="1400" b="0" i="0">
+                <a:solidFill>
+                  <a:srgbClr val="333333"/>
+                </a:solidFill>
+                <a:latin typeface="Calibri"/>
+              </a:rPr>
+              <a:t>Subir evidencias al paquete CloudLite (Drive/repo) y a ExamLab (https://uniaj.examlab.workers.dev/) domingo 23:59.</a:t>
+            </a:r>
+          </a:p>
+        </p:txBody>
+      </p:sp>
+      <p:sp>
+        <p:nvSpPr>
+          <p:cNvPr id="11" name="Rounded Rectangle 10"/>
+          <p:cNvSpPr/>
+          <p:nvPr/>
+        </p:nvSpPr>
+        <p:spPr>
+          <a:xfrm>
+            <a:off x="457200" y="3694176"/>
+            <a:ext cx="11277295" cy="1051560"/>
+          </a:xfrm>
+          <a:prstGeom prst="roundRect">
+            <a:avLst>
+              <a:gd name="adj" fmla="val 12000"/>
+            </a:avLst>
+          </a:prstGeom>
+          <a:solidFill>
+            <a:srgbClr val="FBE4E4"/>
+          </a:solidFill>
+          <a:ln>
+            <a:noFill/>
+          </a:ln>
+        </p:spPr>
+        <p:style>
+          <a:lnRef idx="1">
+            <a:schemeClr val="accent1"/>
+          </a:lnRef>
+          <a:fillRef idx="3">
+            <a:schemeClr val="accent1"/>
+          </a:fillRef>
+          <a:effectRef idx="2">
+            <a:schemeClr val="accent1"/>
+          </a:effectRef>
+          <a:fontRef idx="minor">
+            <a:schemeClr val="lt1"/>
+          </a:fontRef>
+        </p:style>
+        <p:txBody>
+          <a:bodyPr rtlCol="0" anchor="ctr"/>
+          <a:lstStyle/>
+          <a:p>
+            <a:pPr algn="ctr"/>
+          </a:p>
+        </p:txBody>
+      </p:sp>
+      <p:sp>
+        <p:nvSpPr>
+          <p:cNvPr id="12" name="Rectangle 11"/>
+          <p:cNvSpPr/>
+          <p:nvPr/>
+        </p:nvSpPr>
+        <p:spPr>
+          <a:xfrm>
+            <a:off x="457200" y="3694176"/>
+            <a:ext cx="128016" cy="1051560"/>
+          </a:xfrm>
+          <a:prstGeom prst="rect">
+            <a:avLst/>
+          </a:prstGeom>
+          <a:solidFill>
+            <a:srgbClr val="A02030"/>
+          </a:solidFill>
+          <a:ln>
+            <a:noFill/>
+          </a:ln>
+        </p:spPr>
+        <p:style>
+          <a:lnRef idx="1">
+            <a:schemeClr val="accent1"/>
+          </a:lnRef>
+          <a:fillRef idx="3">
+            <a:schemeClr val="accent1"/>
+          </a:fillRef>
+          <a:effectRef idx="2">
+            <a:schemeClr val="accent1"/>
+          </a:effectRef>
+          <a:fontRef idx="minor">
+            <a:schemeClr val="lt1"/>
+          </a:fontRef>
+        </p:style>
+        <p:txBody>
+          <a:bodyPr rtlCol="0" anchor="ctr"/>
+          <a:lstStyle/>
+          <a:p>
+            <a:pPr algn="ctr"/>
+          </a:p>
+        </p:txBody>
+      </p:sp>
+      <p:sp>
+        <p:nvSpPr>
+          <p:cNvPr id="13" name="TextBox 12"/>
+          <p:cNvSpPr txBox="1"/>
+          <p:nvPr/>
+        </p:nvSpPr>
+        <p:spPr>
+          <a:xfrm>
+            <a:off x="777240" y="3831336"/>
+            <a:ext cx="10774375" cy="822959"/>
+          </a:xfrm>
+          <a:prstGeom prst="rect">
+            <a:avLst/>
+          </a:prstGeom>
+          <a:noFill/>
+        </p:spPr>
+        <p:txBody>
+          <a:bodyPr wrap="square">
+            <a:spAutoFit/>
+          </a:bodyPr>
+          <a:lstStyle/>
+          <a:p>
+            <a:r>
+              <a:rPr sz="1200" b="1" i="0">
+                <a:solidFill>
+                  <a:srgbClr val="A02030"/>
+                </a:solidFill>
+                <a:latin typeface="Calibri"/>
+              </a:rPr>
+              <a:t>Atención</a:t>
+            </a:r>
+          </a:p>
+          <a:p>
+            <a:pPr>
+              <a:spcBef>
+                <a:spcPts val="400"/>
+              </a:spcBef>
+            </a:pPr>
+            <a:r>
+              <a:rPr sz="1400" b="0" i="0">
+                <a:solidFill>
+                  <a:srgbClr val="333333"/>
+                </a:solidFill>
+                <a:latin typeface="Calibri"/>
+              </a:rPr>
+              <a:t>Sin cloud de pago ni instalaciones obligatorias de hipervisores/Docker Desktop.</a:t>
+            </a:r>
+          </a:p>
+        </p:txBody>
+      </p:sp>
+      <p:sp>
+        <p:nvSpPr>
+          <p:cNvPr id="14" name="TextBox 13"/>
+          <p:cNvSpPr txBox="1"/>
+          <p:nvPr/>
+        </p:nvSpPr>
+        <p:spPr>
+          <a:xfrm>
+            <a:off x="11185855" y="6473952"/>
+            <a:ext cx="640080" cy="274320"/>
+          </a:xfrm>
+          <a:prstGeom prst="rect">
+            <a:avLst/>
+          </a:prstGeom>
+          <a:noFill/>
+        </p:spPr>
+        <p:txBody>
+          <a:bodyPr wrap="square">
+            <a:spAutoFit/>
+          </a:bodyPr>
+          <a:lstStyle/>
+          <a:p>
+            <a:pPr algn="r"/>
+            <a:r>
+              <a:rPr sz="1100" b="0" i="0">
+                <a:solidFill>
+                  <a:srgbClr val="666666"/>
+                </a:solidFill>
+                <a:latin typeface="Calibri"/>
+              </a:rPr>
+              <a:t>12</a:t>
+            </a:r>
+          </a:p>
+        </p:txBody>
+      </p:sp>
+    </p:spTree>
+  </p:cSld>
+  <p:clrMapOvr>
+    <a:masterClrMapping/>
+  </p:clrMapOvr>
+</p:sld>
+</file>
+
+<file path=ppt/slides/slide13.xml><?xml version="1.0" encoding="utf-8"?>
+<p:sld xmlns:a="http://schemas.openxmlformats.org/drawingml/2006/main" xmlns:p="http://schemas.openxmlformats.org/presentationml/2006/main" xmlns:r="http://schemas.openxmlformats.org/officeDocument/2006/relationships">
+  <p:cSld>
+    <p:bg>
+      <p:bgPr>
+        <a:solidFill>
+          <a:srgbClr val="FFFFFF"/>
+        </a:solidFill>
+        <a:effectLst/>
+      </p:bgPr>
+    </p:bg>
+    <p:spTree>
+      <p:nvGrpSpPr>
+        <p:cNvPr id="1" name=""/>
+        <p:cNvGrpSpPr/>
+        <p:nvPr/>
+      </p:nvGrpSpPr>
+      <p:grpSpPr/>
+      <p:sp>
+        <p:nvSpPr>
+          <p:cNvPr id="2" name="Rectangle 1"/>
+          <p:cNvSpPr/>
+          <p:nvPr/>
+        </p:nvSpPr>
+        <p:spPr>
+          <a:xfrm>
+            <a:off x="0" y="0"/>
             <a:ext cx="12191695" cy="164592"/>
           </a:xfrm>
           <a:prstGeom prst="rect">
@@ -4204,7 +5436,7 @@
                 </a:solidFill>
                 <a:latin typeface="Calibri"/>
               </a:rPr>
-              <a:t>Evidencia: Ficha PI: dominio, capacidades, actores y boceto C4 Context (Excalidraw/draw.io)</a:t>
+              <a:t>Evidencia: Ficha PI de 6 bloques + C4 Context en Mermaid renderizado en ExamLab (boceto previo en Excalidraw/draw.io)</a:t>
             </a:r>
           </a:p>
           <a:p>
@@ -5093,7 +6325,7 @@
                 </a:solidFill>
                 <a:latin typeface="Calibri"/>
               </a:rPr>
-              <a:t> Ficha PI: dominio, capacidades, actores y boceto C4 Context (Excalidraw/draw.io)</a:t>
+              <a:t> Ficha PI de 6 bloques + C4 Context en Mermaid renderizado en ExamLab (boceto previo en Excalidraw/draw.io)</a:t>
             </a:r>
           </a:p>
           <a:p>
@@ -6709,7 +7941,7 @@
         <p:spPr>
           <a:xfrm>
             <a:off x="0" y="0"/>
-            <a:ext cx="12191695" cy="960120"/>
+            <a:ext cx="12191695" cy="1170432"/>
           </a:xfrm>
           <a:prstGeom prst="rect">
             <a:avLst/>
@@ -6751,7 +7983,7 @@
         </p:nvSpPr>
         <p:spPr>
           <a:xfrm>
-            <a:off x="0" y="960120"/>
+            <a:off x="0" y="1170432"/>
             <a:ext cx="12191695" cy="41148"/>
           </a:xfrm>
           <a:prstGeom prst="rect">
@@ -6795,7 +8027,7 @@
         <p:spPr>
           <a:xfrm>
             <a:off x="457200" y="164592"/>
-            <a:ext cx="11277295" cy="502920"/>
+            <a:ext cx="11277295" cy="384048"/>
           </a:xfrm>
           <a:prstGeom prst="rect">
             <a:avLst/>
@@ -6815,7 +8047,7 @@
                 </a:solidFill>
                 <a:latin typeface="Calibri"/>
               </a:rPr>
-              <a:t>Taller PI (paso a paso)</a:t>
+              <a:t>Herramientas de hoy</a:t>
             </a:r>
           </a:p>
         </p:txBody>
@@ -6828,8 +8060,8 @@
         </p:nvSpPr>
         <p:spPr>
           <a:xfrm>
-            <a:off x="457200" y="1170432"/>
-            <a:ext cx="11277295" cy="5230368"/>
+            <a:off x="457200" y="566928"/>
+            <a:ext cx="11277295" cy="411480"/>
           </a:xfrm>
           <a:prstGeom prst="rect">
             <a:avLst/>
@@ -6842,137 +8074,1041 @@
           </a:bodyPr>
           <a:lstStyle/>
           <a:p>
-            <a:pPr>
-              <a:spcAft>
-                <a:spcPts val="800"/>
-              </a:spcAft>
+            <a:r>
+              <a:rPr sz="1400" b="0" i="0">
+                <a:solidFill>
+                  <a:srgbClr val="B8D8EE"/>
+                </a:solidFill>
+                <a:latin typeface="Calibri"/>
+              </a:rPr>
+              <a:t>Gratis · navegador o free tier · sin cuenta de pago</a:t>
+            </a:r>
+          </a:p>
+        </p:txBody>
+      </p:sp>
+      <p:sp>
+        <p:nvSpPr>
+          <p:cNvPr id="6" name="Rounded Rectangle 5"/>
+          <p:cNvSpPr/>
+          <p:nvPr/>
+        </p:nvSpPr>
+        <p:spPr>
+          <a:xfrm>
+            <a:off x="457200" y="1591056"/>
+            <a:ext cx="3624986" cy="2299716"/>
+          </a:xfrm>
+          <a:prstGeom prst="roundRect">
+            <a:avLst>
+              <a:gd name="adj" fmla="val 12000"/>
+            </a:avLst>
+          </a:prstGeom>
+          <a:solidFill>
+            <a:srgbClr val="F2F2F2"/>
+          </a:solidFill>
+          <a:ln>
+            <a:noFill/>
+          </a:ln>
+        </p:spPr>
+        <p:style>
+          <a:lnRef idx="1">
+            <a:schemeClr val="accent1"/>
+          </a:lnRef>
+          <a:fillRef idx="3">
+            <a:schemeClr val="accent1"/>
+          </a:fillRef>
+          <a:effectRef idx="2">
+            <a:schemeClr val="accent1"/>
+          </a:effectRef>
+          <a:fontRef idx="minor">
+            <a:schemeClr val="lt1"/>
+          </a:fontRef>
+        </p:style>
+        <p:txBody>
+          <a:bodyPr rtlCol="0" anchor="ctr"/>
+          <a:lstStyle/>
+          <a:p>
+            <a:pPr algn="ctr"/>
+          </a:p>
+        </p:txBody>
+      </p:sp>
+      <p:sp>
+        <p:nvSpPr>
+          <p:cNvPr id="7" name="Rectangle 6"/>
+          <p:cNvSpPr/>
+          <p:nvPr/>
+        </p:nvSpPr>
+        <p:spPr>
+          <a:xfrm>
+            <a:off x="457200" y="1591056"/>
+            <a:ext cx="3624986" cy="64008"/>
+          </a:xfrm>
+          <a:prstGeom prst="rect">
+            <a:avLst/>
+          </a:prstGeom>
+          <a:solidFill>
+            <a:srgbClr val="095292"/>
+          </a:solidFill>
+          <a:ln>
+            <a:noFill/>
+          </a:ln>
+        </p:spPr>
+        <p:style>
+          <a:lnRef idx="1">
+            <a:schemeClr val="accent1"/>
+          </a:lnRef>
+          <a:fillRef idx="3">
+            <a:schemeClr val="accent1"/>
+          </a:fillRef>
+          <a:effectRef idx="2">
+            <a:schemeClr val="accent1"/>
+          </a:effectRef>
+          <a:fontRef idx="minor">
+            <a:schemeClr val="lt1"/>
+          </a:fontRef>
+        </p:style>
+        <p:txBody>
+          <a:bodyPr rtlCol="0" anchor="ctr"/>
+          <a:lstStyle/>
+          <a:p>
+            <a:pPr algn="ctr"/>
+          </a:p>
+        </p:txBody>
+      </p:sp>
+      <p:sp>
+        <p:nvSpPr>
+          <p:cNvPr id="8" name="Rectangle 7"/>
+          <p:cNvSpPr/>
+          <p:nvPr/>
+        </p:nvSpPr>
+        <p:spPr>
+          <a:xfrm>
+            <a:off x="457200" y="1655064"/>
+            <a:ext cx="3624986" cy="27432"/>
+          </a:xfrm>
+          <a:prstGeom prst="rect">
+            <a:avLst/>
+          </a:prstGeom>
+          <a:solidFill>
+            <a:srgbClr val="FFD000"/>
+          </a:solidFill>
+          <a:ln>
+            <a:noFill/>
+          </a:ln>
+        </p:spPr>
+        <p:style>
+          <a:lnRef idx="1">
+            <a:schemeClr val="accent1"/>
+          </a:lnRef>
+          <a:fillRef idx="3">
+            <a:schemeClr val="accent1"/>
+          </a:fillRef>
+          <a:effectRef idx="2">
+            <a:schemeClr val="accent1"/>
+          </a:effectRef>
+          <a:fontRef idx="minor">
+            <a:schemeClr val="lt1"/>
+          </a:fontRef>
+        </p:style>
+        <p:txBody>
+          <a:bodyPr rtlCol="0" anchor="ctr"/>
+          <a:lstStyle/>
+          <a:p>
+            <a:pPr algn="ctr"/>
+          </a:p>
+        </p:txBody>
+      </p:sp>
+      <p:pic>
+        <p:nvPicPr>
+          <p:cNvPr id="9" name="Picture 8" descr="padlet.png"/>
+          <p:cNvPicPr>
+            <a:picLocks noChangeAspect="1"/>
+          </p:cNvPicPr>
+          <p:nvPr/>
+        </p:nvPicPr>
+        <p:blipFill>
+          <a:blip r:embed="rId2"/>
+          <a:stretch>
+            <a:fillRect/>
+          </a:stretch>
+        </p:blipFill>
+        <p:spPr>
+          <a:xfrm>
+            <a:off x="1659331" y="1847087"/>
+            <a:ext cx="1220724" cy="1220724"/>
+          </a:xfrm>
+          <a:prstGeom prst="rect">
+            <a:avLst/>
+          </a:prstGeom>
+        </p:spPr>
+      </p:pic>
+      <p:sp>
+        <p:nvSpPr>
+          <p:cNvPr id="10" name="TextBox 9"/>
+          <p:cNvSpPr txBox="1"/>
+          <p:nvPr/>
+        </p:nvSpPr>
+        <p:spPr>
+          <a:xfrm>
+            <a:off x="530352" y="3159251"/>
+            <a:ext cx="3478682" cy="621792"/>
+          </a:xfrm>
+          <a:prstGeom prst="rect">
+            <a:avLst/>
+          </a:prstGeom>
+          <a:noFill/>
+        </p:spPr>
+        <p:txBody>
+          <a:bodyPr wrap="square" anchor="t"/>
+          <a:lstStyle/>
+          <a:p>
+            <a:pPr algn="ctr"/>
+            <a:r>
+              <a:rPr sz="1300" b="1" i="0">
+                <a:solidFill>
+                  <a:srgbClr val="095292"/>
+                </a:solidFill>
+                <a:latin typeface="Calibri"/>
+              </a:rPr>
+              <a:t>Padlet</a:t>
+            </a:r>
+          </a:p>
+          <a:p>
+            <a:pPr algn="ctr">
+              <a:spcBef>
+                <a:spcPts val="200"/>
+              </a:spcBef>
             </a:pPr>
             <a:r>
-              <a:rPr sz="1600" b="1" i="0">
-                <a:solidFill>
-                  <a:srgbClr val="333333"/>
-                </a:solidFill>
-                <a:latin typeface="Calibri"/>
-              </a:rPr>
-              <a:t>1.</a:t>
-            </a:r>
-            <a:r>
-              <a:rPr sz="1600" b="0" i="0">
-                <a:solidFill>
-                  <a:srgbClr val="333333"/>
-                </a:solidFill>
-                <a:latin typeface="Calibri"/>
-              </a:rPr>
-              <a:t> Paso 1: elija un dominio concreto entre AgendaU, BiblioLite, InventarioLab, TurnosClinica o EventosCampus (o uno propio del mismo tamano) y escriba el problema en exactamente 3 frases: quien sufre el problema, como se resuelve hoy sin CloudLite y una cifra medible del dolor (por ejemplo 40 correos por semana para cuadrar 12 asesorias), verificando que en ninguna de las 3 frases aparezca una expresion generica como app de la universidad o red social; el resultado queda en la seccion 1 Dominio y problema del informe del PI.</a:t>
-            </a:r>
-          </a:p>
-          <a:p>
-            <a:pPr>
-              <a:spcAft>
-                <a:spcPts val="800"/>
-              </a:spcAft>
+              <a:rPr sz="1000" b="0" i="0">
+                <a:solidFill>
+                  <a:srgbClr val="666666"/>
+                </a:solidFill>
+                <a:latin typeface="Calibri"/>
+              </a:rPr>
+              <a:t>Rompehielos</a:t>
+            </a:r>
+          </a:p>
+        </p:txBody>
+      </p:sp>
+      <p:sp>
+        <p:nvSpPr>
+          <p:cNvPr id="11" name="Rounded Rectangle 10"/>
+          <p:cNvSpPr/>
+          <p:nvPr/>
+        </p:nvSpPr>
+        <p:spPr>
+          <a:xfrm>
+            <a:off x="4283354" y="1591056"/>
+            <a:ext cx="3624986" cy="2299716"/>
+          </a:xfrm>
+          <a:prstGeom prst="roundRect">
+            <a:avLst>
+              <a:gd name="adj" fmla="val 12000"/>
+            </a:avLst>
+          </a:prstGeom>
+          <a:solidFill>
+            <a:srgbClr val="F2F2F2"/>
+          </a:solidFill>
+          <a:ln>
+            <a:noFill/>
+          </a:ln>
+        </p:spPr>
+        <p:style>
+          <a:lnRef idx="1">
+            <a:schemeClr val="accent1"/>
+          </a:lnRef>
+          <a:fillRef idx="3">
+            <a:schemeClr val="accent1"/>
+          </a:fillRef>
+          <a:effectRef idx="2">
+            <a:schemeClr val="accent1"/>
+          </a:effectRef>
+          <a:fontRef idx="minor">
+            <a:schemeClr val="lt1"/>
+          </a:fontRef>
+        </p:style>
+        <p:txBody>
+          <a:bodyPr rtlCol="0" anchor="ctr"/>
+          <a:lstStyle/>
+          <a:p>
+            <a:pPr algn="ctr"/>
+          </a:p>
+        </p:txBody>
+      </p:sp>
+      <p:sp>
+        <p:nvSpPr>
+          <p:cNvPr id="12" name="Rectangle 11"/>
+          <p:cNvSpPr/>
+          <p:nvPr/>
+        </p:nvSpPr>
+        <p:spPr>
+          <a:xfrm>
+            <a:off x="4283354" y="1591056"/>
+            <a:ext cx="3624986" cy="64008"/>
+          </a:xfrm>
+          <a:prstGeom prst="rect">
+            <a:avLst/>
+          </a:prstGeom>
+          <a:solidFill>
+            <a:srgbClr val="095292"/>
+          </a:solidFill>
+          <a:ln>
+            <a:noFill/>
+          </a:ln>
+        </p:spPr>
+        <p:style>
+          <a:lnRef idx="1">
+            <a:schemeClr val="accent1"/>
+          </a:lnRef>
+          <a:fillRef idx="3">
+            <a:schemeClr val="accent1"/>
+          </a:fillRef>
+          <a:effectRef idx="2">
+            <a:schemeClr val="accent1"/>
+          </a:effectRef>
+          <a:fontRef idx="minor">
+            <a:schemeClr val="lt1"/>
+          </a:fontRef>
+        </p:style>
+        <p:txBody>
+          <a:bodyPr rtlCol="0" anchor="ctr"/>
+          <a:lstStyle/>
+          <a:p>
+            <a:pPr algn="ctr"/>
+          </a:p>
+        </p:txBody>
+      </p:sp>
+      <p:sp>
+        <p:nvSpPr>
+          <p:cNvPr id="13" name="Rectangle 12"/>
+          <p:cNvSpPr/>
+          <p:nvPr/>
+        </p:nvSpPr>
+        <p:spPr>
+          <a:xfrm>
+            <a:off x="4283354" y="1655064"/>
+            <a:ext cx="3624986" cy="27432"/>
+          </a:xfrm>
+          <a:prstGeom prst="rect">
+            <a:avLst/>
+          </a:prstGeom>
+          <a:solidFill>
+            <a:srgbClr val="FFD000"/>
+          </a:solidFill>
+          <a:ln>
+            <a:noFill/>
+          </a:ln>
+        </p:spPr>
+        <p:style>
+          <a:lnRef idx="1">
+            <a:schemeClr val="accent1"/>
+          </a:lnRef>
+          <a:fillRef idx="3">
+            <a:schemeClr val="accent1"/>
+          </a:fillRef>
+          <a:effectRef idx="2">
+            <a:schemeClr val="accent1"/>
+          </a:effectRef>
+          <a:fontRef idx="minor">
+            <a:schemeClr val="lt1"/>
+          </a:fontRef>
+        </p:style>
+        <p:txBody>
+          <a:bodyPr rtlCol="0" anchor="ctr"/>
+          <a:lstStyle/>
+          <a:p>
+            <a:pPr algn="ctr"/>
+          </a:p>
+        </p:txBody>
+      </p:sp>
+      <p:pic>
+        <p:nvPicPr>
+          <p:cNvPr id="14" name="Picture 13" descr="excalidraw.png"/>
+          <p:cNvPicPr>
+            <a:picLocks noChangeAspect="1"/>
+          </p:cNvPicPr>
+          <p:nvPr/>
+        </p:nvPicPr>
+        <p:blipFill>
+          <a:blip r:embed="rId3"/>
+          <a:stretch>
+            <a:fillRect/>
+          </a:stretch>
+        </p:blipFill>
+        <p:spPr>
+          <a:xfrm>
+            <a:off x="5485485" y="1847087"/>
+            <a:ext cx="1220724" cy="1220724"/>
+          </a:xfrm>
+          <a:prstGeom prst="rect">
+            <a:avLst/>
+          </a:prstGeom>
+        </p:spPr>
+      </p:pic>
+      <p:sp>
+        <p:nvSpPr>
+          <p:cNvPr id="15" name="TextBox 14"/>
+          <p:cNvSpPr txBox="1"/>
+          <p:nvPr/>
+        </p:nvSpPr>
+        <p:spPr>
+          <a:xfrm>
+            <a:off x="4356506" y="3159251"/>
+            <a:ext cx="3478682" cy="621792"/>
+          </a:xfrm>
+          <a:prstGeom prst="rect">
+            <a:avLst/>
+          </a:prstGeom>
+          <a:noFill/>
+        </p:spPr>
+        <p:txBody>
+          <a:bodyPr wrap="square" anchor="t"/>
+          <a:lstStyle/>
+          <a:p>
+            <a:pPr algn="ctr"/>
+            <a:r>
+              <a:rPr sz="1300" b="1" i="0">
+                <a:solidFill>
+                  <a:srgbClr val="095292"/>
+                </a:solidFill>
+                <a:latin typeface="Calibri"/>
+              </a:rPr>
+              <a:t>Excalidraw</a:t>
+            </a:r>
+          </a:p>
+          <a:p>
+            <a:pPr algn="ctr">
+              <a:spcBef>
+                <a:spcPts val="200"/>
+              </a:spcBef>
             </a:pPr>
             <a:r>
-              <a:rPr sz="1600" b="0" i="0">
-                <a:solidFill>
-                  <a:srgbClr val="333333"/>
-                </a:solidFill>
-                <a:latin typeface="Calibri"/>
-              </a:rPr>
-              <a:t>–   </a:t>
-            </a:r>
-            <a:r>
-              <a:rPr sz="1600" b="1" i="0">
-                <a:solidFill>
-                  <a:srgbClr val="333333"/>
-                </a:solidFill>
-                <a:latin typeface="Calibri"/>
-              </a:rPr>
-              <a:t>2.</a:t>
-            </a:r>
-            <a:r>
-              <a:rPr sz="1600" b="0" i="0">
-                <a:solidFill>
-                  <a:srgbClr val="333333"/>
-                </a:solidFill>
-                <a:latin typeface="Calibri"/>
-              </a:rPr>
-              <a:t> Paso 2: liste exactamente 4 capacidades con la forma verbo mas objeto de negocio (reservar cita, publicar cupo, cancelar reserva, notificar recordatorio), 3 actores humanos con lo que espera cada uno, 2 o 3 sistemas externos con los que CloudLite intercambia informacion (por ejemplo proveedor de identidad, correo transaccional o pasarela de pagos) y 3 elementos de fuera de alcance, verificando que ninguna capacidad nombre tecnologia (nada de usar PostgreSQL ni desplegar en Docker) y que las 4 capacidades se lean como frases del negocio; queda en la seccion 1 del informe y se pega tal cual en la pregunta 1 de ExamLab.</a:t>
-            </a:r>
-          </a:p>
-          <a:p>
-            <a:pPr>
-              <a:spcAft>
-                <a:spcPts val="800"/>
-              </a:spcAft>
+              <a:rPr sz="1000" b="0" i="0">
+                <a:solidFill>
+                  <a:srgbClr val="666666"/>
+                </a:solidFill>
+                <a:latin typeface="Calibri"/>
+              </a:rPr>
+              <a:t>Boceto rapido</a:t>
+            </a:r>
+          </a:p>
+        </p:txBody>
+      </p:sp>
+      <p:sp>
+        <p:nvSpPr>
+          <p:cNvPr id="16" name="Rounded Rectangle 15"/>
+          <p:cNvSpPr/>
+          <p:nvPr/>
+        </p:nvSpPr>
+        <p:spPr>
+          <a:xfrm>
+            <a:off x="8109508" y="1591056"/>
+            <a:ext cx="3624986" cy="2299716"/>
+          </a:xfrm>
+          <a:prstGeom prst="roundRect">
+            <a:avLst>
+              <a:gd name="adj" fmla="val 12000"/>
+            </a:avLst>
+          </a:prstGeom>
+          <a:solidFill>
+            <a:srgbClr val="F2F2F2"/>
+          </a:solidFill>
+          <a:ln>
+            <a:noFill/>
+          </a:ln>
+        </p:spPr>
+        <p:style>
+          <a:lnRef idx="1">
+            <a:schemeClr val="accent1"/>
+          </a:lnRef>
+          <a:fillRef idx="3">
+            <a:schemeClr val="accent1"/>
+          </a:fillRef>
+          <a:effectRef idx="2">
+            <a:schemeClr val="accent1"/>
+          </a:effectRef>
+          <a:fontRef idx="minor">
+            <a:schemeClr val="lt1"/>
+          </a:fontRef>
+        </p:style>
+        <p:txBody>
+          <a:bodyPr rtlCol="0" anchor="ctr"/>
+          <a:lstStyle/>
+          <a:p>
+            <a:pPr algn="ctr"/>
+          </a:p>
+        </p:txBody>
+      </p:sp>
+      <p:sp>
+        <p:nvSpPr>
+          <p:cNvPr id="17" name="Rectangle 16"/>
+          <p:cNvSpPr/>
+          <p:nvPr/>
+        </p:nvSpPr>
+        <p:spPr>
+          <a:xfrm>
+            <a:off x="8109508" y="1591056"/>
+            <a:ext cx="3624986" cy="64008"/>
+          </a:xfrm>
+          <a:prstGeom prst="rect">
+            <a:avLst/>
+          </a:prstGeom>
+          <a:solidFill>
+            <a:srgbClr val="095292"/>
+          </a:solidFill>
+          <a:ln>
+            <a:noFill/>
+          </a:ln>
+        </p:spPr>
+        <p:style>
+          <a:lnRef idx="1">
+            <a:schemeClr val="accent1"/>
+          </a:lnRef>
+          <a:fillRef idx="3">
+            <a:schemeClr val="accent1"/>
+          </a:fillRef>
+          <a:effectRef idx="2">
+            <a:schemeClr val="accent1"/>
+          </a:effectRef>
+          <a:fontRef idx="minor">
+            <a:schemeClr val="lt1"/>
+          </a:fontRef>
+        </p:style>
+        <p:txBody>
+          <a:bodyPr rtlCol="0" anchor="ctr"/>
+          <a:lstStyle/>
+          <a:p>
+            <a:pPr algn="ctr"/>
+          </a:p>
+        </p:txBody>
+      </p:sp>
+      <p:sp>
+        <p:nvSpPr>
+          <p:cNvPr id="18" name="Rectangle 17"/>
+          <p:cNvSpPr/>
+          <p:nvPr/>
+        </p:nvSpPr>
+        <p:spPr>
+          <a:xfrm>
+            <a:off x="8109508" y="1655064"/>
+            <a:ext cx="3624986" cy="27432"/>
+          </a:xfrm>
+          <a:prstGeom prst="rect">
+            <a:avLst/>
+          </a:prstGeom>
+          <a:solidFill>
+            <a:srgbClr val="FFD000"/>
+          </a:solidFill>
+          <a:ln>
+            <a:noFill/>
+          </a:ln>
+        </p:spPr>
+        <p:style>
+          <a:lnRef idx="1">
+            <a:schemeClr val="accent1"/>
+          </a:lnRef>
+          <a:fillRef idx="3">
+            <a:schemeClr val="accent1"/>
+          </a:fillRef>
+          <a:effectRef idx="2">
+            <a:schemeClr val="accent1"/>
+          </a:effectRef>
+          <a:fontRef idx="minor">
+            <a:schemeClr val="lt1"/>
+          </a:fontRef>
+        </p:style>
+        <p:txBody>
+          <a:bodyPr rtlCol="0" anchor="ctr"/>
+          <a:lstStyle/>
+          <a:p>
+            <a:pPr algn="ctr"/>
+          </a:p>
+        </p:txBody>
+      </p:sp>
+      <p:pic>
+        <p:nvPicPr>
+          <p:cNvPr id="19" name="Picture 18" descr="drawio.png"/>
+          <p:cNvPicPr>
+            <a:picLocks noChangeAspect="1"/>
+          </p:cNvPicPr>
+          <p:nvPr/>
+        </p:nvPicPr>
+        <p:blipFill>
+          <a:blip r:embed="rId4"/>
+          <a:stretch>
+            <a:fillRect/>
+          </a:stretch>
+        </p:blipFill>
+        <p:spPr>
+          <a:xfrm>
+            <a:off x="9311640" y="1847087"/>
+            <a:ext cx="1220724" cy="1220724"/>
+          </a:xfrm>
+          <a:prstGeom prst="rect">
+            <a:avLst/>
+          </a:prstGeom>
+        </p:spPr>
+      </p:pic>
+      <p:sp>
+        <p:nvSpPr>
+          <p:cNvPr id="20" name="TextBox 19"/>
+          <p:cNvSpPr txBox="1"/>
+          <p:nvPr/>
+        </p:nvSpPr>
+        <p:spPr>
+          <a:xfrm>
+            <a:off x="8182660" y="3159251"/>
+            <a:ext cx="3478682" cy="621792"/>
+          </a:xfrm>
+          <a:prstGeom prst="rect">
+            <a:avLst/>
+          </a:prstGeom>
+          <a:noFill/>
+        </p:spPr>
+        <p:txBody>
+          <a:bodyPr wrap="square" anchor="t"/>
+          <a:lstStyle/>
+          <a:p>
+            <a:pPr algn="ctr"/>
+            <a:r>
+              <a:rPr sz="1300" b="1" i="0">
+                <a:solidFill>
+                  <a:srgbClr val="095292"/>
+                </a:solidFill>
+                <a:latin typeface="Calibri"/>
+              </a:rPr>
+              <a:t>draw.io</a:t>
+            </a:r>
+          </a:p>
+          <a:p>
+            <a:pPr algn="ctr">
+              <a:spcBef>
+                <a:spcPts val="200"/>
+              </a:spcBef>
             </a:pPr>
             <a:r>
-              <a:rPr sz="1600" b="0" i="0">
-                <a:solidFill>
-                  <a:srgbClr val="333333"/>
-                </a:solidFill>
-                <a:latin typeface="Calibri"/>
-              </a:rPr>
-              <a:t>–   </a:t>
-            </a:r>
-            <a:r>
-              <a:rPr sz="1600" b="1" i="0">
-                <a:solidFill>
-                  <a:srgbClr val="333333"/>
-                </a:solidFill>
-                <a:latin typeface="Calibri"/>
-              </a:rPr>
-              <a:t>3.</a:t>
-            </a:r>
-            <a:r>
-              <a:rPr sz="1600" b="0" i="0">
-                <a:solidFill>
-                  <a:srgbClr val="333333"/>
-                </a:solidFill>
-                <a:latin typeface="Calibri"/>
-              </a:rPr>
-              <a:t> Paso 3: escriba en la pregunta de tipo diagrama de ExamLab el C4 Context en Mermaid con exactamente 1 System para CloudLite, 2 Person, 2 System_Ext y 5 relaciones etiquetadas con verbo de negocio y protocolo, verificando al renderizar dentro de la plataforma que no aparezca ninguna caja interna (ni base de datos ni API ni worker, eso es Clase 4) y que cada flecha se lea en voz alta como una frase completa.</a:t>
-            </a:r>
-          </a:p>
-          <a:p>
-            <a:pPr>
-              <a:spcAft>
-                <a:spcPts val="800"/>
-              </a:spcAft>
+              <a:rPr sz="1000" b="0" i="0">
+                <a:solidFill>
+                  <a:srgbClr val="666666"/>
+                </a:solidFill>
+                <a:latin typeface="Calibri"/>
+              </a:rPr>
+              <a:t>C4 Context</a:t>
+            </a:r>
+          </a:p>
+        </p:txBody>
+      </p:sp>
+      <p:sp>
+        <p:nvSpPr>
+          <p:cNvPr id="21" name="Rounded Rectangle 20"/>
+          <p:cNvSpPr/>
+          <p:nvPr/>
+        </p:nvSpPr>
+        <p:spPr>
+          <a:xfrm>
+            <a:off x="2370277" y="4055364"/>
+            <a:ext cx="3624986" cy="2299716"/>
+          </a:xfrm>
+          <a:prstGeom prst="roundRect">
+            <a:avLst>
+              <a:gd name="adj" fmla="val 12000"/>
+            </a:avLst>
+          </a:prstGeom>
+          <a:solidFill>
+            <a:srgbClr val="F2F2F2"/>
+          </a:solidFill>
+          <a:ln>
+            <a:noFill/>
+          </a:ln>
+        </p:spPr>
+        <p:style>
+          <a:lnRef idx="1">
+            <a:schemeClr val="accent1"/>
+          </a:lnRef>
+          <a:fillRef idx="3">
+            <a:schemeClr val="accent1"/>
+          </a:fillRef>
+          <a:effectRef idx="2">
+            <a:schemeClr val="accent1"/>
+          </a:effectRef>
+          <a:fontRef idx="minor">
+            <a:schemeClr val="lt1"/>
+          </a:fontRef>
+        </p:style>
+        <p:txBody>
+          <a:bodyPr rtlCol="0" anchor="ctr"/>
+          <a:lstStyle/>
+          <a:p>
+            <a:pPr algn="ctr"/>
+          </a:p>
+        </p:txBody>
+      </p:sp>
+      <p:sp>
+        <p:nvSpPr>
+          <p:cNvPr id="22" name="Rectangle 21"/>
+          <p:cNvSpPr/>
+          <p:nvPr/>
+        </p:nvSpPr>
+        <p:spPr>
+          <a:xfrm>
+            <a:off x="2370277" y="4055364"/>
+            <a:ext cx="3624986" cy="64008"/>
+          </a:xfrm>
+          <a:prstGeom prst="rect">
+            <a:avLst/>
+          </a:prstGeom>
+          <a:solidFill>
+            <a:srgbClr val="095292"/>
+          </a:solidFill>
+          <a:ln>
+            <a:noFill/>
+          </a:ln>
+        </p:spPr>
+        <p:style>
+          <a:lnRef idx="1">
+            <a:schemeClr val="accent1"/>
+          </a:lnRef>
+          <a:fillRef idx="3">
+            <a:schemeClr val="accent1"/>
+          </a:fillRef>
+          <a:effectRef idx="2">
+            <a:schemeClr val="accent1"/>
+          </a:effectRef>
+          <a:fontRef idx="minor">
+            <a:schemeClr val="lt1"/>
+          </a:fontRef>
+        </p:style>
+        <p:txBody>
+          <a:bodyPr rtlCol="0" anchor="ctr"/>
+          <a:lstStyle/>
+          <a:p>
+            <a:pPr algn="ctr"/>
+          </a:p>
+        </p:txBody>
+      </p:sp>
+      <p:sp>
+        <p:nvSpPr>
+          <p:cNvPr id="23" name="Rectangle 22"/>
+          <p:cNvSpPr/>
+          <p:nvPr/>
+        </p:nvSpPr>
+        <p:spPr>
+          <a:xfrm>
+            <a:off x="2370277" y="4119372"/>
+            <a:ext cx="3624986" cy="27432"/>
+          </a:xfrm>
+          <a:prstGeom prst="rect">
+            <a:avLst/>
+          </a:prstGeom>
+          <a:solidFill>
+            <a:srgbClr val="FFD000"/>
+          </a:solidFill>
+          <a:ln>
+            <a:noFill/>
+          </a:ln>
+        </p:spPr>
+        <p:style>
+          <a:lnRef idx="1">
+            <a:schemeClr val="accent1"/>
+          </a:lnRef>
+          <a:fillRef idx="3">
+            <a:schemeClr val="accent1"/>
+          </a:fillRef>
+          <a:effectRef idx="2">
+            <a:schemeClr val="accent1"/>
+          </a:effectRef>
+          <a:fontRef idx="minor">
+            <a:schemeClr val="lt1"/>
+          </a:fontRef>
+        </p:style>
+        <p:txBody>
+          <a:bodyPr rtlCol="0" anchor="ctr"/>
+          <a:lstStyle/>
+          <a:p>
+            <a:pPr algn="ctr"/>
+          </a:p>
+        </p:txBody>
+      </p:sp>
+      <p:pic>
+        <p:nvPicPr>
+          <p:cNvPr id="24" name="Picture 23" descr="mermaid.png"/>
+          <p:cNvPicPr>
+            <a:picLocks noChangeAspect="1"/>
+          </p:cNvPicPr>
+          <p:nvPr/>
+        </p:nvPicPr>
+        <p:blipFill>
+          <a:blip r:embed="rId5"/>
+          <a:stretch>
+            <a:fillRect/>
+          </a:stretch>
+        </p:blipFill>
+        <p:spPr>
+          <a:xfrm>
+            <a:off x="3572408" y="4311396"/>
+            <a:ext cx="1220724" cy="1220724"/>
+          </a:xfrm>
+          <a:prstGeom prst="rect">
+            <a:avLst/>
+          </a:prstGeom>
+        </p:spPr>
+      </p:pic>
+      <p:sp>
+        <p:nvSpPr>
+          <p:cNvPr id="25" name="TextBox 24"/>
+          <p:cNvSpPr txBox="1"/>
+          <p:nvPr/>
+        </p:nvSpPr>
+        <p:spPr>
+          <a:xfrm>
+            <a:off x="2443429" y="5623560"/>
+            <a:ext cx="3478682" cy="621792"/>
+          </a:xfrm>
+          <a:prstGeom prst="rect">
+            <a:avLst/>
+          </a:prstGeom>
+          <a:noFill/>
+        </p:spPr>
+        <p:txBody>
+          <a:bodyPr wrap="square" anchor="t"/>
+          <a:lstStyle/>
+          <a:p>
+            <a:pPr algn="ctr"/>
+            <a:r>
+              <a:rPr sz="1300" b="1" i="0">
+                <a:solidFill>
+                  <a:srgbClr val="095292"/>
+                </a:solidFill>
+                <a:latin typeface="Calibri"/>
+              </a:rPr>
+              <a:t>Mermaid</a:t>
+            </a:r>
+          </a:p>
+          <a:p>
+            <a:pPr algn="ctr">
+              <a:spcBef>
+                <a:spcPts val="200"/>
+              </a:spcBef>
             </a:pPr>
             <a:r>
-              <a:rPr sz="1600" b="0" i="0">
-                <a:solidFill>
-                  <a:srgbClr val="333333"/>
-                </a:solidFill>
-                <a:latin typeface="Calibri"/>
-              </a:rPr>
-              <a:t>–   </a:t>
-            </a:r>
-            <a:r>
-              <a:rPr sz="1600" b="1" i="0">
-                <a:solidFill>
-                  <a:srgbClr val="333333"/>
-                </a:solidFill>
-                <a:latin typeface="Calibri"/>
-              </a:rPr>
-              <a:t>4.</a:t>
-            </a:r>
-            <a:r>
-              <a:rPr sz="1600" b="0" i="0">
-                <a:solidFill>
-                  <a:srgbClr val="333333"/>
-                </a:solidFill>
-                <a:latin typeface="Calibri"/>
-              </a:rPr>
-              <a:t> Paso 4: resuelva la tabla comparativa de 4 filas nube frente a on-premise, cierre con el veredicto de 2 frases que sera la entrada del ADR-001 de la Clase 2, y suba a ExamLab (modulo Talleres) las 5 preguntas resueltas antes del domingo 23:59, verificando que la ficha, el diagrama renderizado y el veredicto usen exactamente los mismos nombres de actores y de sistemas externos.</a:t>
-            </a:r>
-          </a:p>
-        </p:txBody>
-      </p:sp>
-      <p:sp>
-        <p:nvSpPr>
-          <p:cNvPr id="6" name="TextBox 5"/>
+              <a:rPr sz="1000" b="0" i="0">
+                <a:solidFill>
+                  <a:srgbClr val="666666"/>
+                </a:solidFill>
+                <a:latin typeface="Calibri"/>
+              </a:rPr>
+              <a:t>Codigo del diagrama</a:t>
+            </a:r>
+          </a:p>
+        </p:txBody>
+      </p:sp>
+      <p:sp>
+        <p:nvSpPr>
+          <p:cNvPr id="26" name="Rounded Rectangle 25"/>
+          <p:cNvSpPr/>
+          <p:nvPr/>
+        </p:nvSpPr>
+        <p:spPr>
+          <a:xfrm>
+            <a:off x="6196431" y="4055364"/>
+            <a:ext cx="3624986" cy="2299716"/>
+          </a:xfrm>
+          <a:prstGeom prst="roundRect">
+            <a:avLst>
+              <a:gd name="adj" fmla="val 12000"/>
+            </a:avLst>
+          </a:prstGeom>
+          <a:solidFill>
+            <a:srgbClr val="F2F2F2"/>
+          </a:solidFill>
+          <a:ln>
+            <a:noFill/>
+          </a:ln>
+        </p:spPr>
+        <p:style>
+          <a:lnRef idx="1">
+            <a:schemeClr val="accent1"/>
+          </a:lnRef>
+          <a:fillRef idx="3">
+            <a:schemeClr val="accent1"/>
+          </a:fillRef>
+          <a:effectRef idx="2">
+            <a:schemeClr val="accent1"/>
+          </a:effectRef>
+          <a:fontRef idx="minor">
+            <a:schemeClr val="lt1"/>
+          </a:fontRef>
+        </p:style>
+        <p:txBody>
+          <a:bodyPr rtlCol="0" anchor="ctr"/>
+          <a:lstStyle/>
+          <a:p>
+            <a:pPr algn="ctr"/>
+          </a:p>
+        </p:txBody>
+      </p:sp>
+      <p:sp>
+        <p:nvSpPr>
+          <p:cNvPr id="27" name="Rectangle 26"/>
+          <p:cNvSpPr/>
+          <p:nvPr/>
+        </p:nvSpPr>
+        <p:spPr>
+          <a:xfrm>
+            <a:off x="6196431" y="4055364"/>
+            <a:ext cx="3624986" cy="64008"/>
+          </a:xfrm>
+          <a:prstGeom prst="rect">
+            <a:avLst/>
+          </a:prstGeom>
+          <a:solidFill>
+            <a:srgbClr val="095292"/>
+          </a:solidFill>
+          <a:ln>
+            <a:noFill/>
+          </a:ln>
+        </p:spPr>
+        <p:style>
+          <a:lnRef idx="1">
+            <a:schemeClr val="accent1"/>
+          </a:lnRef>
+          <a:fillRef idx="3">
+            <a:schemeClr val="accent1"/>
+          </a:fillRef>
+          <a:effectRef idx="2">
+            <a:schemeClr val="accent1"/>
+          </a:effectRef>
+          <a:fontRef idx="minor">
+            <a:schemeClr val="lt1"/>
+          </a:fontRef>
+        </p:style>
+        <p:txBody>
+          <a:bodyPr rtlCol="0" anchor="ctr"/>
+          <a:lstStyle/>
+          <a:p>
+            <a:pPr algn="ctr"/>
+          </a:p>
+        </p:txBody>
+      </p:sp>
+      <p:sp>
+        <p:nvSpPr>
+          <p:cNvPr id="28" name="Rectangle 27"/>
+          <p:cNvSpPr/>
+          <p:nvPr/>
+        </p:nvSpPr>
+        <p:spPr>
+          <a:xfrm>
+            <a:off x="6196431" y="4119372"/>
+            <a:ext cx="3624986" cy="27432"/>
+          </a:xfrm>
+          <a:prstGeom prst="rect">
+            <a:avLst/>
+          </a:prstGeom>
+          <a:solidFill>
+            <a:srgbClr val="FFD000"/>
+          </a:solidFill>
+          <a:ln>
+            <a:noFill/>
+          </a:ln>
+        </p:spPr>
+        <p:style>
+          <a:lnRef idx="1">
+            <a:schemeClr val="accent1"/>
+          </a:lnRef>
+          <a:fillRef idx="3">
+            <a:schemeClr val="accent1"/>
+          </a:fillRef>
+          <a:effectRef idx="2">
+            <a:schemeClr val="accent1"/>
+          </a:effectRef>
+          <a:fontRef idx="minor">
+            <a:schemeClr val="lt1"/>
+          </a:fontRef>
+        </p:style>
+        <p:txBody>
+          <a:bodyPr rtlCol="0" anchor="ctr"/>
+          <a:lstStyle/>
+          <a:p>
+            <a:pPr algn="ctr"/>
+          </a:p>
+        </p:txBody>
+      </p:sp>
+      <p:pic>
+        <p:nvPicPr>
+          <p:cNvPr id="29" name="Picture 28" descr="examlab.png"/>
+          <p:cNvPicPr>
+            <a:picLocks noChangeAspect="1"/>
+          </p:cNvPicPr>
+          <p:nvPr/>
+        </p:nvPicPr>
+        <p:blipFill>
+          <a:blip r:embed="rId6"/>
+          <a:stretch>
+            <a:fillRect/>
+          </a:stretch>
+        </p:blipFill>
+        <p:spPr>
+          <a:xfrm>
+            <a:off x="7398562" y="4311396"/>
+            <a:ext cx="1220724" cy="1220724"/>
+          </a:xfrm>
+          <a:prstGeom prst="rect">
+            <a:avLst/>
+          </a:prstGeom>
+        </p:spPr>
+      </p:pic>
+      <p:sp>
+        <p:nvSpPr>
+          <p:cNvPr id="30" name="TextBox 29"/>
+          <p:cNvSpPr txBox="1"/>
+          <p:nvPr/>
+        </p:nvSpPr>
+        <p:spPr>
+          <a:xfrm>
+            <a:off x="6269583" y="5623560"/>
+            <a:ext cx="3478682" cy="621792"/>
+          </a:xfrm>
+          <a:prstGeom prst="rect">
+            <a:avLst/>
+          </a:prstGeom>
+          <a:noFill/>
+        </p:spPr>
+        <p:txBody>
+          <a:bodyPr wrap="square" anchor="t"/>
+          <a:lstStyle/>
+          <a:p>
+            <a:pPr algn="ctr"/>
+            <a:r>
+              <a:rPr sz="1300" b="1" i="0">
+                <a:solidFill>
+                  <a:srgbClr val="095292"/>
+                </a:solidFill>
+                <a:latin typeface="Calibri"/>
+              </a:rPr>
+              <a:t>ExamLab</a:t>
+            </a:r>
+          </a:p>
+          <a:p>
+            <a:pPr algn="ctr">
+              <a:spcBef>
+                <a:spcPts val="200"/>
+              </a:spcBef>
+            </a:pPr>
+            <a:r>
+              <a:rPr sz="1000" b="0" i="0">
+                <a:solidFill>
+                  <a:srgbClr val="666666"/>
+                </a:solidFill>
+                <a:latin typeface="Calibri"/>
+              </a:rPr>
+              <a:t>Donde se entrega</a:t>
+            </a:r>
+          </a:p>
+        </p:txBody>
+      </p:sp>
+      <p:sp>
+        <p:nvSpPr>
+          <p:cNvPr id="31" name="TextBox 30"/>
           <p:cNvSpPr txBox="1"/>
           <p:nvPr/>
         </p:nvSpPr>

</xml_diff>

<commit_message>
Actividad unica del Corte 1 en ARQ: 15 preguntas para las Clases 1-4
Co-Authored-By: Claude Opus 5 <noreply@anthropic.com>
</commit_message>
<xml_diff>
--- a/Arquitectura de Sistemas Computacionales/Clases/Clase 1 - Introduccion a arquitecturas cloud/Presentacion.pptx
+++ b/Arquitectura de Sistemas Computacionales/Clases/Clase 1 - Introduccion a arquitecturas cloud/Presentacion.pptx
@@ -4591,7 +4591,7 @@
                 </a:solidFill>
                 <a:latin typeface="Calibri"/>
               </a:rPr>
-              <a:t> Paso 3: dibuje primero el boceto del C4 Context en Excalidraw o draw.io, que es donde se piensa el modelo, y despues pidale a una IA que lo traduzca a Mermaid («convierta este diagrama a Mermaid usando C4Context»); peguelo en la pregunta 3 y verifique en el diagrama ya renderizado que el sistema sea UNA sola caja, que no aparezca ninguna caja interna (eso es la pregunta 9) y que cada flecha lleve verbo y protocolo.</a:t>
+              <a:t> Paso 3: dibuje primero el boceto del C4 Context en Excalidraw o draw.io, que es donde se piensa el modelo, y despues pidale a una IA que lo traduzca a Mermaid («convierta este diagrama a Mermaid usando C4Context»); peguelo en la pregunta 3 y verifique en el diagrama ya renderizado que el sistema sea UNA sola caja, que no aparezca ninguna caja interna (eso es la pregunta 13) y que cada flecha lleve verbo y protocolo.</a:t>
             </a:r>
           </a:p>
           <a:p>
@@ -4625,7 +4625,7 @@
                 </a:solidFill>
                 <a:latin typeface="Calibri"/>
               </a:rPr>
-              <a:t> Paso 4: antes de cerrar la sesion, revise que los nombres de actores y de sistemas externos sean EXACTAMENTE los mismos en la ficha y en el diagrama; si no coinciden, no son el mismo sistema, y las preguntas 9 a 11 de esta actividad reutilizan esos nombres. Las preguntas 4 a 11 se resuelven en las Clases 2, 3 y 4: la actividad se entrega completa al cierre del Corte 1, no hoy.</a:t>
+              <a:t> Paso 4: elija en la pregunta 4 dos atributos de calidad de los cuatro del curso, escriba por que pesan en SU dominio y como los mediria con un numero y una unidad, y cierre diciendo cual sacrificaria y que gana a cambio; revise ademas que los nombres de actores y de sistemas externos sean EXACTAMENTE los mismos en la ficha y en el diagrama, porque las preguntas 12 a 15 los reutilizan. Las preguntas 5 a 15 se resuelven en las Clases 2, 3 y 4: la actividad se entrega completa al cierre del Corte 1, no hoy.</a:t>
             </a:r>
           </a:p>
         </p:txBody>

</xml_diff>